<commit_message>
fixed pivots and joins
</commit_message>
<xml_diff>
--- a/docs/content/joins/joins_lecture.pptx
+++ b/docs/content/joins/joins_lecture.pptx
@@ -30,7 +30,6 @@
     <p:sldId id="278" r:id="rId24"/>
     <p:sldId id="279" r:id="rId25"/>
     <p:sldId id="280" r:id="rId26"/>
-    <p:sldId id="281" r:id="rId27"/>
   </p:sldIdLst>
   <p:sldSz cx="9144000" cy="5143500" type="screen16x9"/>
   <p:notesSz cx="6858000" cy="9144000"/>
@@ -3470,7 +3469,7 @@
             </a:pPr>
             <a:r>
               <a:rPr sz="2000" b="1"/>
-              <a:t>🖐 After this chunk: Activity Parts 4–6</a:t>
+              <a:t>🖐 After this chunk: Activity Parts 4–5</a:t>
             </a:r>
             <a:r>
               <a:rPr sz="2000"/>
@@ -4087,7 +4086,7 @@
             </a:pPr>
             <a:r>
               <a:rPr/>
-              <a:t>Live Demo — Watch It Break (a silent wrong join)</a:t>
+              <a:t>🛑 Halfway — Check In</a:t>
             </a:r>
           </a:p>
         </p:txBody>
@@ -4111,366 +4110,124 @@
               <a:buNone/>
             </a:pPr>
             <a:r>
-              <a:rPr/>
-              <a:t>If I forget </a:t>
-            </a:r>
-            <a:r>
-              <a:rPr>
-                <a:latin typeface="Courier"/>
-              </a:rPr>
-              <a:t>by = ...</a:t>
-            </a:r>
-            <a:r>
-              <a:rPr/>
-              <a:t>, dplyr looks for a </a:t>
-            </a:r>
-            <a:r>
               <a:rPr b="1"/>
-              <a:t>shared column name</a:t>
-            </a:r>
-            <a:r>
-              <a:rPr/>
-              <a:t> — and both tables have a </a:t>
-            </a:r>
-            <a:r>
-              <a:rPr b="1">
-                <a:latin typeface="Courier"/>
-              </a:rPr>
-              <a:t>site</a:t>
-            </a:r>
-            <a:r>
-              <a:rPr/>
-              <a:t> column:</a:t>
-            </a:r>
-          </a:p>
-          <a:p>
-            <a:pPr lvl="0" indent="0">
-              <a:buNone/>
-            </a:pPr>
-            <a:r>
-              <a:rPr>
-                <a:solidFill>
-                  <a:srgbClr val="003B4F"/>
-                </a:solidFill>
-                <a:latin typeface="Courier"/>
-              </a:rPr>
-              <a:t>captures_df </a:t>
-            </a:r>
-            <a:r>
-              <a:rPr>
-                <a:solidFill>
-                  <a:srgbClr val="5E5E5E"/>
-                </a:solidFill>
-                <a:latin typeface="Courier"/>
-              </a:rPr>
-              <a:t>%&gt;%</a:t>
-            </a:r>
-            <a:r>
-              <a:rPr>
-                <a:solidFill>
-                  <a:srgbClr val="003B4F"/>
-                </a:solidFill>
-                <a:latin typeface="Courier"/>
-              </a:rPr>
-              <a:t> </a:t>
-            </a:r>
-            <a:r>
-              <a:rPr>
-                <a:solidFill>
-                  <a:srgbClr val="4758AB"/>
-                </a:solidFill>
+              <a:t>So far you can:</a:t>
+            </a:r>
+          </a:p>
+          <a:p>
+            <a:pPr lvl="0"/>
+            <a:r>
+              <a:rPr/>
+              <a:t>Explain a key and why it must be unique (in the lookup table) and the same case/type in both tables</a:t>
+            </a:r>
+          </a:p>
+          <a:p>
+            <a:pPr lvl="0"/>
+            <a:r>
+              <a:rPr/>
+              <a:t>Join two tables whose key columns are named differently</a:t>
+            </a:r>
+          </a:p>
+          <a:p>
+            <a:pPr lvl="0"/>
+            <a:r>
+              <a:rPr/>
+              <a:t>Use </a:t>
+            </a:r>
+            <a:r>
+              <a:rPr>
+                <a:latin typeface="Courier"/>
+              </a:rPr>
+              <a:t>left_join()</a:t>
+            </a:r>
+            <a:r>
+              <a:rPr/>
+              <a:t> to keep every row on the left</a:t>
+            </a:r>
+          </a:p>
+        </p:txBody>
+      </p:sp>
+      <p:sp>
+        <p:nvSpPr>
+          <p:cNvPr id="4" name="Content Placeholder 3"/>
+          <p:cNvSpPr>
+            <a:spLocks noGrp="1"/>
+          </p:cNvSpPr>
+          <p:nvPr>
+            <p:ph idx="2" sz="half"/>
+          </p:nvPr>
+        </p:nvSpPr>
+        <p:spPr/>
+        <p:txBody>
+          <a:bodyPr/>
+          <a:lstStyle/>
+          <a:p>
+            <a:pPr lvl="0" indent="0" marL="0">
+              <a:buNone/>
+            </a:pPr>
+            <a:r>
+              <a:rPr b="1"/>
+              <a:t>Still to come — the rest of the family:</a:t>
+            </a:r>
+          </a:p>
+          <a:p>
+            <a:pPr lvl="0"/>
+            <a:r>
+              <a:rPr>
+                <a:latin typeface="Courier"/>
+              </a:rPr>
+              <a:t>inner_join</a:t>
+            </a:r>
+            <a:r>
+              <a:rPr/>
+              <a:t> vs </a:t>
+            </a:r>
+            <a:r>
+              <a:rPr>
                 <a:latin typeface="Courier"/>
               </a:rPr>
               <a:t>left_join</a:t>
             </a:r>
             <a:r>
-              <a:rPr>
-                <a:solidFill>
-                  <a:srgbClr val="003B4F"/>
-                </a:solidFill>
-                <a:latin typeface="Courier"/>
-              </a:rPr>
-              <a:t>(individuals_df)</a:t>
-            </a:r>
-            <a:br/>
-            <a:r>
-              <a:rPr>
-                <a:solidFill>
-                  <a:srgbClr val="5E5E5E"/>
-                </a:solidFill>
-                <a:latin typeface="Courier"/>
-              </a:rPr>
-              <a:t>#&gt; Joining with `by = join_by(site)`</a:t>
-            </a:r>
-          </a:p>
-          <a:p>
-            <a:pPr lvl="0" indent="0" marL="0">
-              <a:buNone/>
-            </a:pPr>
-            <a:r>
-              <a:rPr/>
-              <a:t>But </a:t>
-            </a:r>
-            <a:r>
-              <a:rPr>
-                <a:latin typeface="Courier"/>
-              </a:rPr>
-              <a:t>site</a:t>
-            </a:r>
-            <a:r>
-              <a:rPr/>
-              <a:t> means different things: the </a:t>
+              <a:rPr/>
+              <a:t> vs </a:t>
+            </a:r>
+            <a:r>
+              <a:rPr>
+                <a:latin typeface="Courier"/>
+              </a:rPr>
+              <a:t>full_join</a:t>
+            </a:r>
+          </a:p>
+          <a:p>
+            <a:pPr lvl="0"/>
+            <a:r>
+              <a:rPr>
+                <a:latin typeface="Courier"/>
+              </a:rPr>
+              <a:t>semi_join</a:t>
+            </a:r>
+            <a:r>
+              <a:rPr/>
+              <a:t> and </a:t>
+            </a:r>
+            <a:r>
+              <a:rPr>
+                <a:latin typeface="Courier"/>
+              </a:rPr>
+              <a:t>anti_join</a:t>
+            </a:r>
+            <a:r>
+              <a:rPr/>
+              <a:t> to </a:t>
             </a:r>
             <a:r>
               <a:rPr b="1"/>
-              <a:t>capture</a:t>
-            </a:r>
-            <a:r>
-              <a:rPr/>
-              <a:t> site vs the </a:t>
-            </a:r>
-            <a:r>
-              <a:rPr b="1"/>
-              <a:t>release</a:t>
-            </a:r>
-            <a:r>
-              <a:rPr/>
-              <a:t> site. Joining on it matches a capture to </a:t>
-            </a:r>
-            <a:r>
-              <a:rPr i="1"/>
-              <a:t>every fisher released at that site</a:t>
-            </a:r>
-            <a:r>
-              <a:rPr/>
-              <a:t> — the row count explodes and the animal ids are nonsense. </a:t>
-            </a:r>
-            <a:r>
-              <a:rPr b="1"/>
-              <a:t>No error.</a:t>
-            </a:r>
-          </a:p>
-          <a:p>
-            <a:pPr lvl="0" indent="0" marL="0">
-              <a:buNone/>
-            </a:pPr>
-            <a:r>
-              <a:rPr/>
-              <a:t>The fix — always name the real key:</a:t>
-            </a:r>
-          </a:p>
-          <a:p>
-            <a:pPr lvl="0" indent="0">
-              <a:buNone/>
-            </a:pPr>
-            <a:r>
-              <a:rPr>
-                <a:solidFill>
-                  <a:srgbClr val="003B4F"/>
-                </a:solidFill>
-                <a:latin typeface="Courier"/>
-              </a:rPr>
-              <a:t>captures_df </a:t>
-            </a:r>
-            <a:r>
-              <a:rPr>
-                <a:solidFill>
-                  <a:srgbClr val="5E5E5E"/>
-                </a:solidFill>
-                <a:latin typeface="Courier"/>
-              </a:rPr>
-              <a:t>%&gt;%</a:t>
-            </a:r>
-            <a:br/>
-            <a:r>
-              <a:rPr>
-                <a:solidFill>
-                  <a:srgbClr val="003B4F"/>
-                </a:solidFill>
-                <a:latin typeface="Courier"/>
-              </a:rPr>
-              <a:t>  </a:t>
-            </a:r>
-            <a:r>
-              <a:rPr>
-                <a:solidFill>
-                  <a:srgbClr val="4758AB"/>
-                </a:solidFill>
-                <a:latin typeface="Courier"/>
-              </a:rPr>
-              <a:t>left_join</a:t>
-            </a:r>
-            <a:r>
-              <a:rPr>
-                <a:solidFill>
-                  <a:srgbClr val="003B4F"/>
-                </a:solidFill>
-                <a:latin typeface="Courier"/>
-              </a:rPr>
-              <a:t>(individuals_df, </a:t>
-            </a:r>
-            <a:r>
-              <a:rPr>
-                <a:solidFill>
-                  <a:srgbClr val="657422"/>
-                </a:solidFill>
-                <a:latin typeface="Courier"/>
-              </a:rPr>
-              <a:t>by =</a:t>
-            </a:r>
-            <a:r>
-              <a:rPr>
-                <a:solidFill>
-                  <a:srgbClr val="003B4F"/>
-                </a:solidFill>
-                <a:latin typeface="Courier"/>
-              </a:rPr>
-              <a:t> </a:t>
-            </a:r>
-            <a:r>
-              <a:rPr>
-                <a:solidFill>
-                  <a:srgbClr val="4758AB"/>
-                </a:solidFill>
-                <a:latin typeface="Courier"/>
-              </a:rPr>
-              <a:t>c</a:t>
-            </a:r>
-            <a:r>
-              <a:rPr>
-                <a:solidFill>
-                  <a:srgbClr val="003B4F"/>
-                </a:solidFill>
-                <a:latin typeface="Courier"/>
-              </a:rPr>
-              <a:t>(</a:t>
-            </a:r>
-            <a:r>
-              <a:rPr>
-                <a:solidFill>
-                  <a:srgbClr val="20794D"/>
-                </a:solidFill>
-                <a:latin typeface="Courier"/>
-              </a:rPr>
-              <a:t>"animal_id"</a:t>
-            </a:r>
-            <a:r>
-              <a:rPr>
-                <a:solidFill>
-                  <a:srgbClr val="003B4F"/>
-                </a:solidFill>
-                <a:latin typeface="Courier"/>
-              </a:rPr>
-              <a:t> = </a:t>
-            </a:r>
-            <a:r>
-              <a:rPr>
-                <a:solidFill>
-                  <a:srgbClr val="20794D"/>
-                </a:solidFill>
-                <a:latin typeface="Courier"/>
-              </a:rPr>
-              <a:t>"fisher_id"</a:t>
-            </a:r>
-            <a:r>
-              <a:rPr>
-                <a:solidFill>
-                  <a:srgbClr val="003B4F"/>
-                </a:solidFill>
-                <a:latin typeface="Courier"/>
-              </a:rPr>
-              <a:t>))</a:t>
-            </a:r>
-          </a:p>
-        </p:txBody>
-      </p:sp>
-      <p:sp>
-        <p:nvSpPr>
-          <p:cNvPr id="4" name="Content Placeholder 3"/>
-          <p:cNvSpPr>
-            <a:spLocks noGrp="1"/>
-          </p:cNvSpPr>
-          <p:nvPr>
-            <p:ph idx="2" sz="half"/>
-          </p:nvPr>
-        </p:nvSpPr>
-        <p:spPr/>
-        <p:txBody>
-          <a:bodyPr/>
-          <a:lstStyle/>
-          <a:p>
-            <a:pPr lvl="0" indent="0" marL="1270000">
-              <a:buNone/>
-            </a:pPr>
-            <a:r>
-              <a:rPr sz="2000" b="1"/>
-              <a:t>Important</a:t>
-            </a:r>
-          </a:p>
-          <a:p>
-            <a:pPr lvl="0" indent="0" marL="1270000">
-              <a:buNone/>
-            </a:pPr>
-            <a:r>
-              <a:rPr sz="2000" b="1"/>
-              <a:t>✅ Why show a silent wrong join?</a:t>
-            </a:r>
-          </a:p>
-          <a:p>
-            <a:pPr lvl="0" indent="0" marL="1270000">
-              <a:buNone/>
-            </a:pPr>
-            <a:r>
-              <a:rPr sz="2000"/>
-              <a:t>Nothing throws an error, so nothing forces you to notice. </a:t>
-            </a:r>
-            <a:r>
-              <a:rPr sz="2000">
-                <a:latin typeface="Courier"/>
-              </a:rPr>
-              <a:t>captures_df</a:t>
-            </a:r>
-            <a:r>
-              <a:rPr sz="2000"/>
-              <a:t> and </a:t>
-            </a:r>
-            <a:r>
-              <a:rPr sz="2000">
-                <a:latin typeface="Courier"/>
-              </a:rPr>
-              <a:t>individuals_df</a:t>
-            </a:r>
-            <a:r>
-              <a:rPr sz="2000"/>
-              <a:t> both have a </a:t>
-            </a:r>
-            <a:r>
-              <a:rPr sz="2000">
-                <a:latin typeface="Courier"/>
-              </a:rPr>
-              <a:t>site</a:t>
-            </a:r>
-            <a:r>
-              <a:rPr sz="2000"/>
-              <a:t> column; dplyr matches on it happily and hands you hundreds of rows that pair a capture with the wrong animal. If the message </a:t>
-            </a:r>
-            <a:r>
-              <a:rPr sz="2000" i="1"/>
-              <a:t>“Joining with </a:t>
-            </a:r>
-            <a:r>
-              <a:rPr sz="2000" i="1">
-                <a:latin typeface="Courier"/>
-              </a:rPr>
-              <a:t>by = ...</a:t>
-            </a:r>
-            <a:r>
-              <a:rPr sz="2000" i="1"/>
-              <a:t>”</a:t>
-            </a:r>
-            <a:r>
-              <a:rPr sz="2000"/>
-              <a:t> names a column you didn’t pick, treat it as a bug report, not a status update.</a:t>
+              <a:t>filter</a:t>
+            </a:r>
+            <a:r>
+              <a:rPr/>
+              <a:t> instead of add columns</a:t>
             </a:r>
           </a:p>
         </p:txBody>
@@ -4510,11 +4267,8 @@
         <p:spPr>
           <a:xfrm>
             <a:off x="0" y="0"/>
-            <a:ext cx="9144000" cy="602780"/>
+            <a:ext cx="9144000" cy="582780"/>
           </a:xfrm>
-          <a:solidFill>
-            <a:srgbClr val="1A1A2E"/>
-          </a:solidFill>
         </p:spPr>
         <p:txBody>
           <a:bodyPr/>
@@ -4525,7 +4279,7 @@
             </a:pPr>
             <a:r>
               <a:rPr/>
-              <a:t>🛑 Halfway — Check In</a:t>
+              <a:t>🧩 Chunk 3 of 4 · The Join Family</a:t>
             </a:r>
           </a:p>
         </p:txBody>
@@ -4537,7 +4291,7 @@
             <a:spLocks noGrp="1"/>
           </p:cNvSpPr>
           <p:nvPr>
-            <p:ph idx="1" sz="half"/>
+            <p:ph idx="1"/>
           </p:nvPr>
         </p:nvSpPr>
         <p:spPr/>
@@ -4550,67 +4304,12 @@
             </a:pPr>
             <a:r>
               <a:rPr b="1"/>
-              <a:t>So far you can:</a:t>
-            </a:r>
-          </a:p>
-          <a:p>
-            <a:pPr lvl="0"/>
-            <a:r>
-              <a:rPr/>
-              <a:t>Explain a key and why it must be unique (in the lookup table) and the same case/type in both tables</a:t>
-            </a:r>
-          </a:p>
-          <a:p>
-            <a:pPr lvl="0"/>
-            <a:r>
-              <a:rPr/>
-              <a:t>Join two tables whose key columns are named differently</a:t>
-            </a:r>
-          </a:p>
-          <a:p>
-            <a:pPr lvl="0"/>
-            <a:r>
-              <a:rPr/>
-              <a:t>Use </a:t>
-            </a:r>
-            <a:r>
-              <a:rPr>
-                <a:latin typeface="Courier"/>
-              </a:rPr>
-              <a:t>left_join()</a:t>
-            </a:r>
-            <a:r>
-              <a:rPr/>
-              <a:t> to keep every row on the left</a:t>
-            </a:r>
-          </a:p>
-        </p:txBody>
-      </p:sp>
-      <p:sp>
-        <p:nvSpPr>
-          <p:cNvPr id="4" name="Content Placeholder 3"/>
-          <p:cNvSpPr>
-            <a:spLocks noGrp="1"/>
-          </p:cNvSpPr>
-          <p:nvPr>
-            <p:ph idx="2" sz="half"/>
-          </p:nvPr>
-        </p:nvSpPr>
-        <p:spPr/>
-        <p:txBody>
-          <a:bodyPr/>
-          <a:lstStyle/>
-          <a:p>
-            <a:pPr lvl="0" indent="0" marL="0">
-              <a:buNone/>
-            </a:pPr>
-            <a:r>
-              <a:rPr b="1"/>
-              <a:t>Still to come — the rest of the family:</a:t>
-            </a:r>
-          </a:p>
-          <a:p>
-            <a:pPr lvl="0"/>
+              <a:t>We will cover:</a:t>
+            </a:r>
+            <a:r>
+              <a:rPr/>
+              <a:t> </a:t>
+            </a:r>
             <a:r>
               <a:rPr>
                 <a:latin typeface="Courier"/>
@@ -4619,7 +4318,7 @@
             </a:r>
             <a:r>
               <a:rPr/>
-              <a:t> vs </a:t>
+              <a:t>, </a:t>
             </a:r>
             <a:r>
               <a:rPr>
@@ -4629,7 +4328,7 @@
             </a:r>
             <a:r>
               <a:rPr/>
-              <a:t> vs </a:t>
+              <a:t>, and </a:t>
             </a:r>
             <a:r>
               <a:rPr>
@@ -4637,36 +4336,31 @@
               </a:rPr>
               <a:t>full_join</a:t>
             </a:r>
-          </a:p>
-          <a:p>
-            <a:pPr lvl="0"/>
-            <a:r>
-              <a:rPr>
-                <a:latin typeface="Courier"/>
-              </a:rPr>
-              <a:t>semi_join</a:t>
-            </a:r>
-            <a:r>
-              <a:rPr/>
-              <a:t> and </a:t>
-            </a:r>
-            <a:r>
-              <a:rPr>
-                <a:latin typeface="Courier"/>
-              </a:rPr>
-              <a:t>anti_join</a:t>
-            </a:r>
-            <a:r>
-              <a:rPr/>
-              <a:t> to </a:t>
-            </a:r>
-            <a:r>
-              <a:rPr b="1"/>
-              <a:t>filter</a:t>
-            </a:r>
-            <a:r>
-              <a:rPr/>
-              <a:t> instead of add columns</a:t>
+            <a:r>
+              <a:rPr/>
+              <a:t>, and how to choose.</a:t>
+            </a:r>
+          </a:p>
+          <a:p>
+            <a:pPr lvl="0" indent="0" marL="1270000">
+              <a:buNone/>
+            </a:pPr>
+            <a:r>
+              <a:rPr sz="2000" b="1"/>
+              <a:t>Tip</a:t>
+            </a:r>
+          </a:p>
+          <a:p>
+            <a:pPr lvl="0" indent="0" marL="1270000">
+              <a:buNone/>
+            </a:pPr>
+            <a:r>
+              <a:rPr sz="2000" b="1"/>
+              <a:t>🖐 After this chunk: Activity Parts 6–8</a:t>
+            </a:r>
+            <a:r>
+              <a:rPr sz="2000"/>
+              <a:t> (compare the three joins).</a:t>
             </a:r>
           </a:p>
         </p:txBody>
@@ -4718,7 +4412,7 @@
             </a:pPr>
             <a:r>
               <a:rPr/>
-              <a:t>🧩 Chunk 3 of 4 · The Join Family</a:t>
+              <a:t>Inner vs. Left vs. Full</a:t>
             </a:r>
           </a:p>
         </p:txBody>
@@ -4738,68 +4432,63 @@
           <a:bodyPr/>
           <a:lstStyle/>
           <a:p>
-            <a:pPr lvl="0" indent="0" marL="0">
-              <a:buNone/>
-            </a:pPr>
-            <a:r>
-              <a:rPr b="1"/>
-              <a:t>We will cover:</a:t>
-            </a:r>
-            <a:r>
-              <a:rPr/>
-              <a:t> </a:t>
-            </a:r>
-            <a:r>
-              <a:rPr>
+            <a:pPr lvl="0" indent="0" marL="1270000">
+              <a:buNone/>
+            </a:pPr>
+            <a:r>
+              <a:rPr sz="2000" b="1"/>
+              <a:t>Note</a:t>
+            </a:r>
+          </a:p>
+          <a:p>
+            <a:pPr lvl="0" indent="0" marL="1270000">
+              <a:buNone/>
+            </a:pPr>
+            <a:r>
+              <a:rPr sz="2000" b="1"/>
+              <a:t>🔮 Predict first:</a:t>
+            </a:r>
+            <a:r>
+              <a:rPr sz="2000"/>
+              <a:t> Rank by row count: </a:t>
+            </a:r>
+            <a:r>
+              <a:rPr sz="2000">
                 <a:latin typeface="Courier"/>
               </a:rPr>
               <a:t>inner_join</a:t>
             </a:r>
             <a:r>
-              <a:rPr/>
-              <a:t>, </a:t>
-            </a:r>
-            <a:r>
-              <a:rPr>
+              <a:rPr sz="2000"/>
+              <a:t> (only matches), </a:t>
+            </a:r>
+            <a:r>
+              <a:rPr sz="2000">
                 <a:latin typeface="Courier"/>
               </a:rPr>
               <a:t>left_join</a:t>
             </a:r>
             <a:r>
-              <a:rPr/>
-              <a:t>, and </a:t>
-            </a:r>
-            <a:r>
-              <a:rPr>
+              <a:rPr sz="2000"/>
+              <a:t> (all captures), </a:t>
+            </a:r>
+            <a:r>
+              <a:rPr sz="2000">
                 <a:latin typeface="Courier"/>
               </a:rPr>
               <a:t>full_join</a:t>
             </a:r>
             <a:r>
-              <a:rPr/>
-              <a:t>, and how to choose.</a:t>
-            </a:r>
-          </a:p>
-          <a:p>
-            <a:pPr lvl="0" indent="0" marL="1270000">
-              <a:buNone/>
-            </a:pPr>
+              <a:rPr sz="2000"/>
+              <a:t> (all captures </a:t>
+            </a:r>
             <a:r>
               <a:rPr sz="2000" b="1"/>
-              <a:t>Tip</a:t>
-            </a:r>
-          </a:p>
-          <a:p>
-            <a:pPr lvl="0" indent="0" marL="1270000">
-              <a:buNone/>
-            </a:pPr>
-            <a:r>
-              <a:rPr sz="2000" b="1"/>
-              <a:t>🖐 After this chunk: Activity Parts 7–9</a:t>
+              <a:t>and</a:t>
             </a:r>
             <a:r>
               <a:rPr sz="2000"/>
-              <a:t> (compare the three joins).</a:t>
+              <a:t> every released fisher, even the never-recaptured ones).</a:t>
             </a:r>
           </a:p>
         </p:txBody>
@@ -4810,134 +4499,6 @@
 </file>
 
 <file path=ppt/slides/slide16.xml><?xml version="1.0" encoding="utf-8"?>
-<p:sld xmlns:a="http://schemas.openxmlformats.org/drawingml/2006/main" xmlns:r="http://schemas.openxmlformats.org/officeDocument/2006/relationships" xmlns:p="http://schemas.openxmlformats.org/presentationml/2006/main">
-  <p:cSld>
-    <p:spTree>
-      <p:nvGrpSpPr>
-        <p:cNvPr id="1" name=""/>
-        <p:cNvGrpSpPr/>
-        <p:nvPr/>
-      </p:nvGrpSpPr>
-      <p:grpSpPr>
-        <a:xfrm>
-          <a:off x="0" y="0"/>
-          <a:ext cx="0" cy="0"/>
-          <a:chOff x="0" y="0"/>
-          <a:chExt cx="0" cy="0"/>
-        </a:xfrm>
-      </p:grpSpPr>
-      <p:sp>
-        <p:nvSpPr>
-          <p:cNvPr id="2" name="Title 1"/>
-          <p:cNvSpPr>
-            <a:spLocks noGrp="1"/>
-          </p:cNvSpPr>
-          <p:nvPr>
-            <p:ph type="title"/>
-          </p:nvPr>
-        </p:nvSpPr>
-        <p:spPr>
-          <a:xfrm>
-            <a:off x="0" y="0"/>
-            <a:ext cx="9144000" cy="582780"/>
-          </a:xfrm>
-        </p:spPr>
-        <p:txBody>
-          <a:bodyPr/>
-          <a:lstStyle/>
-          <a:p>
-            <a:pPr lvl="0" indent="0" marL="0">
-              <a:buNone/>
-            </a:pPr>
-            <a:r>
-              <a:rPr/>
-              <a:t>Inner vs. Left vs. Full</a:t>
-            </a:r>
-          </a:p>
-        </p:txBody>
-      </p:sp>
-      <p:sp>
-        <p:nvSpPr>
-          <p:cNvPr id="3" name="Content Placeholder 2"/>
-          <p:cNvSpPr>
-            <a:spLocks noGrp="1"/>
-          </p:cNvSpPr>
-          <p:nvPr>
-            <p:ph idx="1"/>
-          </p:nvPr>
-        </p:nvSpPr>
-        <p:spPr/>
-        <p:txBody>
-          <a:bodyPr/>
-          <a:lstStyle/>
-          <a:p>
-            <a:pPr lvl="0" indent="0" marL="1270000">
-              <a:buNone/>
-            </a:pPr>
-            <a:r>
-              <a:rPr sz="2000" b="1"/>
-              <a:t>Note</a:t>
-            </a:r>
-          </a:p>
-          <a:p>
-            <a:pPr lvl="0" indent="0" marL="1270000">
-              <a:buNone/>
-            </a:pPr>
-            <a:r>
-              <a:rPr sz="2000" b="1"/>
-              <a:t>🔮 Predict first:</a:t>
-            </a:r>
-            <a:r>
-              <a:rPr sz="2000"/>
-              <a:t> Rank by row count: </a:t>
-            </a:r>
-            <a:r>
-              <a:rPr sz="2000">
-                <a:latin typeface="Courier"/>
-              </a:rPr>
-              <a:t>inner_join</a:t>
-            </a:r>
-            <a:r>
-              <a:rPr sz="2000"/>
-              <a:t> (only matches), </a:t>
-            </a:r>
-            <a:r>
-              <a:rPr sz="2000">
-                <a:latin typeface="Courier"/>
-              </a:rPr>
-              <a:t>left_join</a:t>
-            </a:r>
-            <a:r>
-              <a:rPr sz="2000"/>
-              <a:t> (all captures), </a:t>
-            </a:r>
-            <a:r>
-              <a:rPr sz="2000">
-                <a:latin typeface="Courier"/>
-              </a:rPr>
-              <a:t>full_join</a:t>
-            </a:r>
-            <a:r>
-              <a:rPr sz="2000"/>
-              <a:t> (all captures </a:t>
-            </a:r>
-            <a:r>
-              <a:rPr sz="2000" b="1"/>
-              <a:t>and</a:t>
-            </a:r>
-            <a:r>
-              <a:rPr sz="2000"/>
-              <a:t> every released fisher, even the never-recaptured ones).</a:t>
-            </a:r>
-          </a:p>
-        </p:txBody>
-      </p:sp>
-    </p:spTree>
-  </p:cSld>
-</p:sld>
-</file>
-
-<file path=ppt/slides/slide17.xml><?xml version="1.0" encoding="utf-8"?>
 <p:sld xmlns:a="http://schemas.openxmlformats.org/drawingml/2006/main" xmlns:r="http://schemas.openxmlformats.org/officeDocument/2006/relationships" xmlns:p="http://schemas.openxmlformats.org/presentationml/2006/main">
   <p:cSld>
     <p:spTree>
@@ -5516,6 +5077,188 @@
 </p:sld>
 </file>
 
+<file path=ppt/slides/slide17.xml><?xml version="1.0" encoding="utf-8"?>
+<p:sld xmlns:a="http://schemas.openxmlformats.org/drawingml/2006/main" xmlns:r="http://schemas.openxmlformats.org/officeDocument/2006/relationships" xmlns:p="http://schemas.openxmlformats.org/presentationml/2006/main">
+  <p:cSld>
+    <p:spTree>
+      <p:nvGrpSpPr>
+        <p:cNvPr id="1" name=""/>
+        <p:cNvGrpSpPr/>
+        <p:nvPr/>
+      </p:nvGrpSpPr>
+      <p:grpSpPr>
+        <a:xfrm>
+          <a:off x="0" y="0"/>
+          <a:ext cx="0" cy="0"/>
+          <a:chOff x="0" y="0"/>
+          <a:chExt cx="0" cy="0"/>
+        </a:xfrm>
+      </p:grpSpPr>
+      <p:sp>
+        <p:nvSpPr>
+          <p:cNvPr id="2" name="Title 1"/>
+          <p:cNvSpPr>
+            <a:spLocks noGrp="1"/>
+          </p:cNvSpPr>
+          <p:nvPr>
+            <p:ph type="title"/>
+          </p:nvPr>
+        </p:nvSpPr>
+        <p:spPr>
+          <a:xfrm>
+            <a:off x="0" y="0"/>
+            <a:ext cx="9144000" cy="602780"/>
+          </a:xfrm>
+          <a:solidFill>
+            <a:srgbClr val="1A1A2E"/>
+          </a:solidFill>
+        </p:spPr>
+        <p:txBody>
+          <a:bodyPr/>
+          <a:lstStyle/>
+          <a:p>
+            <a:pPr lvl="0" indent="0" marL="0">
+              <a:buNone/>
+            </a:pPr>
+            <a:r>
+              <a:rPr/>
+              <a:t>Which Join Should You Use?</a:t>
+            </a:r>
+          </a:p>
+        </p:txBody>
+      </p:sp>
+      <p:sp>
+        <p:nvSpPr>
+          <p:cNvPr id="3" name="Content Placeholder 2"/>
+          <p:cNvSpPr>
+            <a:spLocks noGrp="1"/>
+          </p:cNvSpPr>
+          <p:nvPr>
+            <p:ph idx="1" sz="half"/>
+          </p:nvPr>
+        </p:nvSpPr>
+        <p:spPr/>
+        <p:txBody>
+          <a:bodyPr/>
+          <a:lstStyle/>
+          <a:p>
+            <a:pPr lvl="0"/>
+            <a:r>
+              <a:rPr b="1">
+                <a:latin typeface="Courier"/>
+              </a:rPr>
+              <a:t>left_join</a:t>
+            </a:r>
+            <a:r>
+              <a:rPr/>
+              <a:t> — the default. Keep everything on your main table, add what you can. </a:t>
+            </a:r>
+            <a:r>
+              <a:rPr i="1"/>
+              <a:t>(Event-level analysis: keep all captures.)</a:t>
+            </a:r>
+          </a:p>
+          <a:p>
+            <a:pPr lvl="0"/>
+            <a:r>
+              <a:rPr b="1">
+                <a:latin typeface="Courier"/>
+              </a:rPr>
+              <a:t>inner_join</a:t>
+            </a:r>
+            <a:r>
+              <a:rPr/>
+              <a:t> — only rows with a match. </a:t>
+            </a:r>
+            <a:r>
+              <a:rPr i="1"/>
+              <a:t>(When an unattributed event would ruin the analysis.)</a:t>
+            </a:r>
+          </a:p>
+          <a:p>
+            <a:pPr lvl="0"/>
+            <a:r>
+              <a:rPr b="1">
+                <a:latin typeface="Courier"/>
+              </a:rPr>
+              <a:t>full_join</a:t>
+            </a:r>
+            <a:r>
+              <a:rPr/>
+              <a:t> — keep everything from both. </a:t>
+            </a:r>
+            <a:r>
+              <a:rPr i="1"/>
+              <a:t>(To audit what’s missing on each side — which fishers vanished.)</a:t>
+            </a:r>
+          </a:p>
+        </p:txBody>
+      </p:sp>
+      <p:sp>
+        <p:nvSpPr>
+          <p:cNvPr id="4" name="Content Placeholder 3"/>
+          <p:cNvSpPr>
+            <a:spLocks noGrp="1"/>
+          </p:cNvSpPr>
+          <p:nvPr>
+            <p:ph idx="2" sz="half"/>
+          </p:nvPr>
+        </p:nvSpPr>
+        <p:spPr/>
+        <p:txBody>
+          <a:bodyPr/>
+          <a:lstStyle/>
+          <a:p>
+            <a:pPr lvl="0" indent="0" marL="1270000">
+              <a:buNone/>
+            </a:pPr>
+            <a:r>
+              <a:rPr sz="2000" b="1"/>
+              <a:t>Note</a:t>
+            </a:r>
+          </a:p>
+          <a:p>
+            <a:pPr lvl="0" indent="0" marL="1270000">
+              <a:buNone/>
+            </a:pPr>
+            <a:r>
+              <a:rPr sz="2000" b="1"/>
+              <a:t>✅ Choosing among the three</a:t>
+            </a:r>
+          </a:p>
+          <a:p>
+            <a:pPr lvl="0" indent="0" marL="1270000">
+              <a:buNone/>
+            </a:pPr>
+            <a:r>
+              <a:rPr sz="2000"/>
+              <a:t>Ask which rows you’d be upset to lose. Drop an unmarked capture and you undercount effort; drop a never-recaptured fisher from a </a:t>
+            </a:r>
+            <a:r>
+              <a:rPr sz="2000" i="1"/>
+              <a:t>survival</a:t>
+            </a:r>
+            <a:r>
+              <a:rPr sz="2000"/>
+              <a:t> analysis and you bias it badly. Match the join to the question.</a:t>
+            </a:r>
+          </a:p>
+          <a:p>
+            <a:pPr lvl="0" indent="0" marL="0">
+              <a:buNone/>
+            </a:pPr>
+            <a:r>
+              <a:rPr/>
+              <a:t>📖 R4DS §19.3–19.4</a:t>
+            </a:r>
+          </a:p>
+        </p:txBody>
+      </p:sp>
+    </p:spTree>
+  </p:cSld>
+</p:sld>
+</file>
+
 <file path=ppt/slides/slide18.xml><?xml version="1.0" encoding="utf-8"?>
 <p:sld xmlns:a="http://schemas.openxmlformats.org/drawingml/2006/main" xmlns:r="http://schemas.openxmlformats.org/officeDocument/2006/relationships" xmlns:p="http://schemas.openxmlformats.org/presentationml/2006/main">
   <p:cSld>
@@ -5546,11 +5289,8 @@
         <p:spPr>
           <a:xfrm>
             <a:off x="0" y="0"/>
-            <a:ext cx="9144000" cy="602780"/>
+            <a:ext cx="9144000" cy="582780"/>
           </a:xfrm>
-          <a:solidFill>
-            <a:srgbClr val="1A1A2E"/>
-          </a:solidFill>
         </p:spPr>
         <p:txBody>
           <a:bodyPr/>
@@ -5561,7 +5301,7 @@
             </a:pPr>
             <a:r>
               <a:rPr/>
-              <a:t>Which Join Should You Use?</a:t>
+              <a:t>🛑 Pause — Do Activity Parts 6–8 Now</a:t>
             </a:r>
           </a:p>
         </p:txBody>
@@ -5573,7 +5313,7 @@
             <a:spLocks noGrp="1"/>
           </p:cNvSpPr>
           <p:nvPr>
-            <p:ph idx="1" sz="half"/>
+            <p:ph idx="1"/>
           </p:nvPr>
         </p:nvSpPr>
         <p:spPr/>
@@ -5581,114 +5321,12 @@
           <a:bodyPr/>
           <a:lstStyle/>
           <a:p>
-            <a:pPr lvl="0"/>
-            <a:r>
-              <a:rPr b="1">
-                <a:latin typeface="Courier"/>
-              </a:rPr>
-              <a:t>left_join</a:t>
-            </a:r>
-            <a:r>
-              <a:rPr/>
-              <a:t> — the default. Keep everything on your main table, add what you can. </a:t>
-            </a:r>
-            <a:r>
-              <a:rPr i="1"/>
-              <a:t>(Event-level analysis: keep all captures.)</a:t>
-            </a:r>
-          </a:p>
-          <a:p>
-            <a:pPr lvl="0"/>
-            <a:r>
-              <a:rPr b="1">
-                <a:latin typeface="Courier"/>
-              </a:rPr>
-              <a:t>inner_join</a:t>
-            </a:r>
-            <a:r>
-              <a:rPr/>
-              <a:t> — only rows with a match. </a:t>
-            </a:r>
-            <a:r>
-              <a:rPr i="1"/>
-              <a:t>(When an unattributed event would ruin the analysis.)</a:t>
-            </a:r>
-          </a:p>
-          <a:p>
-            <a:pPr lvl="0"/>
-            <a:r>
-              <a:rPr b="1">
-                <a:latin typeface="Courier"/>
-              </a:rPr>
-              <a:t>full_join</a:t>
-            </a:r>
-            <a:r>
-              <a:rPr/>
-              <a:t> — keep everything from both. </a:t>
-            </a:r>
-            <a:r>
-              <a:rPr i="1"/>
-              <a:t>(To audit what’s missing on each side — which fishers vanished.)</a:t>
-            </a:r>
-          </a:p>
-        </p:txBody>
-      </p:sp>
-      <p:sp>
-        <p:nvSpPr>
-          <p:cNvPr id="4" name="Content Placeholder 3"/>
-          <p:cNvSpPr>
-            <a:spLocks noGrp="1"/>
-          </p:cNvSpPr>
-          <p:nvPr>
-            <p:ph idx="2" sz="half"/>
-          </p:nvPr>
-        </p:nvSpPr>
-        <p:spPr/>
-        <p:txBody>
-          <a:bodyPr/>
-          <a:lstStyle/>
-          <a:p>
-            <a:pPr lvl="0" indent="0" marL="1270000">
-              <a:buNone/>
-            </a:pPr>
-            <a:r>
-              <a:rPr sz="2000" b="1"/>
-              <a:t>Note</a:t>
-            </a:r>
-          </a:p>
-          <a:p>
-            <a:pPr lvl="0" indent="0" marL="1270000">
-              <a:buNone/>
-            </a:pPr>
-            <a:r>
-              <a:rPr sz="2000" b="1"/>
-              <a:t>✅ Choosing among the three</a:t>
-            </a:r>
-          </a:p>
-          <a:p>
-            <a:pPr lvl="0" indent="0" marL="1270000">
-              <a:buNone/>
-            </a:pPr>
-            <a:r>
-              <a:rPr sz="2000"/>
-              <a:t>Ask which rows you’d be upset to lose. Drop an unmarked capture and you undercount effort; drop a never-recaptured fisher from a </a:t>
-            </a:r>
-            <a:r>
-              <a:rPr sz="2000" i="1"/>
-              <a:t>survival</a:t>
-            </a:r>
-            <a:r>
-              <a:rPr sz="2000"/>
-              <a:t> analysis and you bias it badly. Match the join to the question.</a:t>
-            </a:r>
-          </a:p>
-          <a:p>
             <a:pPr lvl="0" indent="0" marL="0">
               <a:buNone/>
             </a:pPr>
             <a:r>
               <a:rPr/>
-              <a:t>📖 R4DS §19.3–19.4</a:t>
+              <a:t>Run all three joins, compare the row counts, and decide which one you’d use to build a map. Predict each count first.</a:t>
             </a:r>
           </a:p>
         </p:txBody>
@@ -5740,7 +5378,7 @@
             </a:pPr>
             <a:r>
               <a:rPr/>
-              <a:t>🛑 Pause — Do Activity Parts 7–9 Now</a:t>
+              <a:t>🧩 Chunk 4 of 4 · Filtering Joins &amp; the Payoff</a:t>
             </a:r>
           </a:p>
         </p:txBody>
@@ -5764,8 +5402,62 @@
               <a:buNone/>
             </a:pPr>
             <a:r>
-              <a:rPr/>
-              <a:t>Run all three joins, compare the row counts, and decide which one you’d use to build a map. Predict each count first.</a:t>
+              <a:rPr b="1"/>
+              <a:t>We will cover:</a:t>
+            </a:r>
+            <a:r>
+              <a:rPr/>
+              <a:t> </a:t>
+            </a:r>
+            <a:r>
+              <a:rPr>
+                <a:latin typeface="Courier"/>
+              </a:rPr>
+              <a:t>semi_join</a:t>
+            </a:r>
+            <a:r>
+              <a:rPr/>
+              <a:t> and </a:t>
+            </a:r>
+            <a:r>
+              <a:rPr>
+                <a:latin typeface="Courier"/>
+              </a:rPr>
+              <a:t>anti_join</a:t>
+            </a:r>
+            <a:r>
+              <a:rPr/>
+              <a:t> — joins that </a:t>
+            </a:r>
+            <a:r>
+              <a:rPr b="1"/>
+              <a:t>filter</a:t>
+            </a:r>
+            <a:r>
+              <a:rPr/>
+              <a:t> rather than add columns.</a:t>
+            </a:r>
+          </a:p>
+          <a:p>
+            <a:pPr lvl="0" indent="0" marL="1270000">
+              <a:buNone/>
+            </a:pPr>
+            <a:r>
+              <a:rPr sz="2000" b="1"/>
+              <a:t>Tip</a:t>
+            </a:r>
+          </a:p>
+          <a:p>
+            <a:pPr lvl="0" indent="0" marL="1270000">
+              <a:buNone/>
+            </a:pPr>
+            <a:r>
+              <a:rPr sz="2000" b="1"/>
+              <a:t>🖐 After this chunk: Activity Parts 9–11</a:t>
+            </a:r>
+            <a:r>
+              <a:rPr sz="2000"/>
+              <a:t> (find what didn’t match, then build the analysis-ready table).</a:t>
             </a:r>
           </a:p>
         </p:txBody>
@@ -6019,8 +5711,14 @@
               <a:buNone/>
             </a:pPr>
             <a:r>
-              <a:rPr/>
-              <a:t>🧩 Chunk 4 of 4 · Filtering Joins &amp; the Payoff</a:t>
+              <a:rPr>
+                <a:latin typeface="Courier"/>
+              </a:rPr>
+              <a:t>anti_join()</a:t>
+            </a:r>
+            <a:r>
+              <a:rPr/>
+              <a:t> — What Didn’t Match?</a:t>
             </a:r>
           </a:p>
         </p:txBody>
@@ -6040,53 +5738,12 @@
           <a:bodyPr/>
           <a:lstStyle/>
           <a:p>
-            <a:pPr lvl="0" indent="0" marL="0">
-              <a:buNone/>
-            </a:pPr>
-            <a:r>
-              <a:rPr b="1"/>
-              <a:t>We will cover:</a:t>
-            </a:r>
-            <a:r>
-              <a:rPr/>
-              <a:t> </a:t>
-            </a:r>
-            <a:r>
-              <a:rPr>
-                <a:latin typeface="Courier"/>
-              </a:rPr>
-              <a:t>semi_join</a:t>
-            </a:r>
-            <a:r>
-              <a:rPr/>
-              <a:t> and </a:t>
-            </a:r>
-            <a:r>
-              <a:rPr>
-                <a:latin typeface="Courier"/>
-              </a:rPr>
-              <a:t>anti_join</a:t>
-            </a:r>
-            <a:r>
-              <a:rPr/>
-              <a:t> — joins that </a:t>
-            </a:r>
-            <a:r>
-              <a:rPr b="1"/>
-              <a:t>filter</a:t>
-            </a:r>
-            <a:r>
-              <a:rPr/>
-              <a:t> rather than add columns.</a:t>
-            </a:r>
-          </a:p>
-          <a:p>
             <a:pPr lvl="0" indent="0" marL="1270000">
               <a:buNone/>
             </a:pPr>
             <a:r>
               <a:rPr sz="2000" b="1"/>
-              <a:t>Tip</a:t>
+              <a:t>Note</a:t>
             </a:r>
           </a:p>
           <a:p>
@@ -6095,11 +5752,27 @@
             </a:pPr>
             <a:r>
               <a:rPr sz="2000" b="1"/>
-              <a:t>🖐 After this chunk: Activity Parts 10–12</a:t>
+              <a:t>🔮 Predict first (two ways):</a:t>
             </a:r>
             <a:r>
               <a:rPr sz="2000"/>
-              <a:t> (find what didn’t match, then build the analysis-ready table).</a:t>
+              <a:t> how many capture </a:t>
+            </a:r>
+            <a:r>
+              <a:rPr sz="2000" b="1"/>
+              <a:t>events</a:t>
+            </a:r>
+            <a:r>
+              <a:rPr sz="2000"/>
+              <a:t> have no known animal? How many released </a:t>
+            </a:r>
+            <a:r>
+              <a:rPr sz="2000" b="1"/>
+              <a:t>fishers</a:t>
+            </a:r>
+            <a:r>
+              <a:rPr sz="2000"/>
+              <a:t> were never recaptured?</a:t>
             </a:r>
           </a:p>
         </p:txBody>
@@ -6128,90 +5801,462 @@
       </p:grpSpPr>
       <p:sp>
         <p:nvSpPr>
-          <p:cNvPr id="2" name="Title 1"/>
-          <p:cNvSpPr>
-            <a:spLocks noGrp="1"/>
-          </p:cNvSpPr>
-          <p:nvPr>
-            <p:ph type="title"/>
-          </p:nvPr>
-        </p:nvSpPr>
-        <p:spPr>
-          <a:xfrm>
-            <a:off x="0" y="0"/>
-            <a:ext cx="9144000" cy="582780"/>
-          </a:xfrm>
-        </p:spPr>
+          <p:cNvPr id="3" name="Content Placeholder 2"/>
+          <p:cNvSpPr>
+            <a:spLocks noGrp="1"/>
+          </p:cNvSpPr>
+          <p:nvPr>
+            <p:ph idx="1" sz="half"/>
+          </p:nvPr>
+        </p:nvSpPr>
+        <p:spPr/>
         <p:txBody>
           <a:bodyPr/>
           <a:lstStyle/>
           <a:p>
+            <a:pPr lvl="0" indent="0">
+              <a:buNone/>
+            </a:pPr>
+            <a:r>
+              <a:rPr>
+                <a:solidFill>
+                  <a:srgbClr val="5E5E5E"/>
+                </a:solidFill>
+                <a:latin typeface="Courier"/>
+              </a:rPr>
+              <a:t># (a) capture events of unmarked animals</a:t>
+            </a:r>
+            <a:br/>
+            <a:r>
+              <a:rPr>
+                <a:solidFill>
+                  <a:srgbClr val="003B4F"/>
+                </a:solidFill>
+                <a:latin typeface="Courier"/>
+              </a:rPr>
+              <a:t>captures_df </a:t>
+            </a:r>
+            <a:r>
+              <a:rPr>
+                <a:solidFill>
+                  <a:srgbClr val="5E5E5E"/>
+                </a:solidFill>
+                <a:latin typeface="Courier"/>
+              </a:rPr>
+              <a:t>%&gt;%</a:t>
+            </a:r>
+            <a:br/>
+            <a:r>
+              <a:rPr>
+                <a:solidFill>
+                  <a:srgbClr val="003B4F"/>
+                </a:solidFill>
+                <a:latin typeface="Courier"/>
+              </a:rPr>
+              <a:t>  </a:t>
+            </a:r>
+            <a:r>
+              <a:rPr>
+                <a:solidFill>
+                  <a:srgbClr val="4758AB"/>
+                </a:solidFill>
+                <a:latin typeface="Courier"/>
+              </a:rPr>
+              <a:t>anti_join</a:t>
+            </a:r>
+            <a:r>
+              <a:rPr>
+                <a:solidFill>
+                  <a:srgbClr val="003B4F"/>
+                </a:solidFill>
+                <a:latin typeface="Courier"/>
+              </a:rPr>
+              <a:t>(individuals_df,</a:t>
+            </a:r>
+            <a:br/>
+            <a:r>
+              <a:rPr>
+                <a:solidFill>
+                  <a:srgbClr val="003B4F"/>
+                </a:solidFill>
+                <a:latin typeface="Courier"/>
+              </a:rPr>
+              <a:t>            </a:t>
+            </a:r>
+            <a:r>
+              <a:rPr>
+                <a:solidFill>
+                  <a:srgbClr val="657422"/>
+                </a:solidFill>
+                <a:latin typeface="Courier"/>
+              </a:rPr>
+              <a:t>by =</a:t>
+            </a:r>
+            <a:r>
+              <a:rPr>
+                <a:solidFill>
+                  <a:srgbClr val="003B4F"/>
+                </a:solidFill>
+                <a:latin typeface="Courier"/>
+              </a:rPr>
+              <a:t> </a:t>
+            </a:r>
+            <a:r>
+              <a:rPr>
+                <a:solidFill>
+                  <a:srgbClr val="4758AB"/>
+                </a:solidFill>
+                <a:latin typeface="Courier"/>
+              </a:rPr>
+              <a:t>c</a:t>
+            </a:r>
+            <a:r>
+              <a:rPr>
+                <a:solidFill>
+                  <a:srgbClr val="003B4F"/>
+                </a:solidFill>
+                <a:latin typeface="Courier"/>
+              </a:rPr>
+              <a:t>(</a:t>
+            </a:r>
+            <a:r>
+              <a:rPr>
+                <a:solidFill>
+                  <a:srgbClr val="20794D"/>
+                </a:solidFill>
+                <a:latin typeface="Courier"/>
+              </a:rPr>
+              <a:t>"animal_id"</a:t>
+            </a:r>
+            <a:r>
+              <a:rPr>
+                <a:solidFill>
+                  <a:srgbClr val="003B4F"/>
+                </a:solidFill>
+                <a:latin typeface="Courier"/>
+              </a:rPr>
+              <a:t> = </a:t>
+            </a:r>
+            <a:r>
+              <a:rPr>
+                <a:solidFill>
+                  <a:srgbClr val="20794D"/>
+                </a:solidFill>
+                <a:latin typeface="Courier"/>
+              </a:rPr>
+              <a:t>"fisher_id"</a:t>
+            </a:r>
+            <a:r>
+              <a:rPr>
+                <a:solidFill>
+                  <a:srgbClr val="003B4F"/>
+                </a:solidFill>
+                <a:latin typeface="Courier"/>
+              </a:rPr>
+              <a:t>)) </a:t>
+            </a:r>
+            <a:r>
+              <a:rPr>
+                <a:solidFill>
+                  <a:srgbClr val="5E5E5E"/>
+                </a:solidFill>
+                <a:latin typeface="Courier"/>
+              </a:rPr>
+              <a:t>%&gt;%</a:t>
+            </a:r>
+            <a:br/>
+            <a:r>
+              <a:rPr>
+                <a:solidFill>
+                  <a:srgbClr val="003B4F"/>
+                </a:solidFill>
+                <a:latin typeface="Courier"/>
+              </a:rPr>
+              <a:t>  </a:t>
+            </a:r>
+            <a:r>
+              <a:rPr>
+                <a:solidFill>
+                  <a:srgbClr val="4758AB"/>
+                </a:solidFill>
+                <a:latin typeface="Courier"/>
+              </a:rPr>
+              <a:t>nrow</a:t>
+            </a:r>
+            <a:r>
+              <a:rPr>
+                <a:solidFill>
+                  <a:srgbClr val="003B4F"/>
+                </a:solidFill>
+                <a:latin typeface="Courier"/>
+              </a:rPr>
+              <a:t>()</a:t>
+            </a:r>
+          </a:p>
+          <a:p>
+            <a:pPr lvl="0" indent="0">
+              <a:buNone/>
+            </a:pPr>
+            <a:r>
+              <a:rPr>
+                <a:latin typeface="Courier"/>
+              </a:rPr>
+              <a:t>[1] 3</a:t>
+            </a:r>
+          </a:p>
+          <a:p>
+            <a:pPr lvl="0" indent="0">
+              <a:buNone/>
+            </a:pPr>
+            <a:r>
+              <a:rPr>
+                <a:solidFill>
+                  <a:srgbClr val="5E5E5E"/>
+                </a:solidFill>
+                <a:latin typeface="Courier"/>
+              </a:rPr>
+              <a:t># (b) released fishers with no capture — anti_join the OTHER way</a:t>
+            </a:r>
+            <a:br/>
+            <a:r>
+              <a:rPr>
+                <a:solidFill>
+                  <a:srgbClr val="003B4F"/>
+                </a:solidFill>
+                <a:latin typeface="Courier"/>
+              </a:rPr>
+              <a:t>individuals_df </a:t>
+            </a:r>
+            <a:r>
+              <a:rPr>
+                <a:solidFill>
+                  <a:srgbClr val="5E5E5E"/>
+                </a:solidFill>
+                <a:latin typeface="Courier"/>
+              </a:rPr>
+              <a:t>%&gt;%</a:t>
+            </a:r>
+            <a:br/>
+            <a:r>
+              <a:rPr>
+                <a:solidFill>
+                  <a:srgbClr val="003B4F"/>
+                </a:solidFill>
+                <a:latin typeface="Courier"/>
+              </a:rPr>
+              <a:t>  </a:t>
+            </a:r>
+            <a:r>
+              <a:rPr>
+                <a:solidFill>
+                  <a:srgbClr val="4758AB"/>
+                </a:solidFill>
+                <a:latin typeface="Courier"/>
+              </a:rPr>
+              <a:t>anti_join</a:t>
+            </a:r>
+            <a:r>
+              <a:rPr>
+                <a:solidFill>
+                  <a:srgbClr val="003B4F"/>
+                </a:solidFill>
+                <a:latin typeface="Courier"/>
+              </a:rPr>
+              <a:t>(captures_df, </a:t>
+            </a:r>
+            <a:r>
+              <a:rPr>
+                <a:solidFill>
+                  <a:srgbClr val="657422"/>
+                </a:solidFill>
+                <a:latin typeface="Courier"/>
+              </a:rPr>
+              <a:t>by =</a:t>
+            </a:r>
+            <a:r>
+              <a:rPr>
+                <a:solidFill>
+                  <a:srgbClr val="003B4F"/>
+                </a:solidFill>
+                <a:latin typeface="Courier"/>
+              </a:rPr>
+              <a:t> </a:t>
+            </a:r>
+            <a:r>
+              <a:rPr>
+                <a:solidFill>
+                  <a:srgbClr val="4758AB"/>
+                </a:solidFill>
+                <a:latin typeface="Courier"/>
+              </a:rPr>
+              <a:t>c</a:t>
+            </a:r>
+            <a:r>
+              <a:rPr>
+                <a:solidFill>
+                  <a:srgbClr val="003B4F"/>
+                </a:solidFill>
+                <a:latin typeface="Courier"/>
+              </a:rPr>
+              <a:t>(</a:t>
+            </a:r>
+            <a:r>
+              <a:rPr>
+                <a:solidFill>
+                  <a:srgbClr val="20794D"/>
+                </a:solidFill>
+                <a:latin typeface="Courier"/>
+              </a:rPr>
+              <a:t>"fisher_id"</a:t>
+            </a:r>
+            <a:r>
+              <a:rPr>
+                <a:solidFill>
+                  <a:srgbClr val="003B4F"/>
+                </a:solidFill>
+                <a:latin typeface="Courier"/>
+              </a:rPr>
+              <a:t> = </a:t>
+            </a:r>
+            <a:r>
+              <a:rPr>
+                <a:solidFill>
+                  <a:srgbClr val="20794D"/>
+                </a:solidFill>
+                <a:latin typeface="Courier"/>
+              </a:rPr>
+              <a:t>"animal_id"</a:t>
+            </a:r>
+            <a:r>
+              <a:rPr>
+                <a:solidFill>
+                  <a:srgbClr val="003B4F"/>
+                </a:solidFill>
+                <a:latin typeface="Courier"/>
+              </a:rPr>
+              <a:t>)) </a:t>
+            </a:r>
+            <a:r>
+              <a:rPr>
+                <a:solidFill>
+                  <a:srgbClr val="5E5E5E"/>
+                </a:solidFill>
+                <a:latin typeface="Courier"/>
+              </a:rPr>
+              <a:t>%&gt;%</a:t>
+            </a:r>
+            <a:br/>
+            <a:r>
+              <a:rPr>
+                <a:solidFill>
+                  <a:srgbClr val="003B4F"/>
+                </a:solidFill>
+                <a:latin typeface="Courier"/>
+              </a:rPr>
+              <a:t>  </a:t>
+            </a:r>
+            <a:r>
+              <a:rPr>
+                <a:solidFill>
+                  <a:srgbClr val="4758AB"/>
+                </a:solidFill>
+                <a:latin typeface="Courier"/>
+              </a:rPr>
+              <a:t>select</a:t>
+            </a:r>
+            <a:r>
+              <a:rPr>
+                <a:solidFill>
+                  <a:srgbClr val="003B4F"/>
+                </a:solidFill>
+                <a:latin typeface="Courier"/>
+              </a:rPr>
+              <a:t>(fisher_id, sex, site)</a:t>
+            </a:r>
+          </a:p>
+          <a:p>
+            <a:pPr lvl="0" indent="0">
+              <a:buNone/>
+            </a:pPr>
+            <a:r>
+              <a:rPr>
+                <a:latin typeface="Courier"/>
+              </a:rPr>
+              <a:t># A tibble: 4 × 3
+  fisher_id sex   site           
+  &lt;chr&gt;     &lt;chr&gt; &lt;chr&gt;          
+1 F04       F     Snoqualmie     
+2 F11       F     Gifford Pinchot
+3 F17       M     Snoqualmie     
+4 F18       F     Mt Rainier     </a:t>
+            </a:r>
+          </a:p>
+        </p:txBody>
+      </p:sp>
+      <p:sp>
+        <p:nvSpPr>
+          <p:cNvPr id="4" name="Content Placeholder 3"/>
+          <p:cNvSpPr>
+            <a:spLocks noGrp="1"/>
+          </p:cNvSpPr>
+          <p:nvPr>
+            <p:ph idx="2" sz="half"/>
+          </p:nvPr>
+        </p:nvSpPr>
+        <p:spPr/>
+        <p:txBody>
+          <a:bodyPr/>
+          <a:lstStyle/>
+          <a:p>
+            <a:pPr lvl="0"/>
+            <a:r>
+              <a:rPr b="1">
+                <a:latin typeface="Courier"/>
+              </a:rPr>
+              <a:t>anti_join</a:t>
+            </a:r>
+            <a:r>
+              <a:rPr/>
+              <a:t> keeps the left rows with </a:t>
+            </a:r>
+            <a:r>
+              <a:rPr b="1"/>
+              <a:t>no</a:t>
+            </a:r>
+            <a:r>
+              <a:rPr/>
+              <a:t> match — “what’s missing?”</a:t>
+            </a:r>
+          </a:p>
+          <a:p>
+            <a:pPr lvl="0"/>
+            <a:r>
+              <a:rPr/>
+              <a:t>It </a:t>
+            </a:r>
+            <a:r>
+              <a:rPr b="1"/>
+              <a:t>adds no columns</a:t>
+            </a:r>
+            <a:r>
+              <a:rPr/>
+              <a:t> — it filters</a:t>
+            </a:r>
+          </a:p>
+          <a:p>
+            <a:pPr lvl="0"/>
+            <a:r>
+              <a:rPr/>
+              <a:t>Direction matters: run it both ways to see each side’s gaps</a:t>
+            </a:r>
+          </a:p>
+          <a:p>
             <a:pPr lvl="0" indent="0" marL="0">
               <a:buNone/>
             </a:pPr>
             <a:r>
-              <a:rPr>
-                <a:latin typeface="Courier"/>
-              </a:rPr>
-              <a:t>anti_join()</a:t>
-            </a:r>
-            <a:r>
-              <a:rPr/>
-              <a:t> — What Didn’t Match?</a:t>
-            </a:r>
-          </a:p>
-        </p:txBody>
-      </p:sp>
-      <p:sp>
-        <p:nvSpPr>
-          <p:cNvPr id="3" name="Content Placeholder 2"/>
-          <p:cNvSpPr>
-            <a:spLocks noGrp="1"/>
-          </p:cNvSpPr>
-          <p:nvPr>
-            <p:ph idx="1"/>
-          </p:nvPr>
-        </p:nvSpPr>
-        <p:spPr/>
-        <p:txBody>
-          <a:bodyPr/>
-          <a:lstStyle/>
-          <a:p>
-            <a:pPr lvl="0" indent="0" marL="1270000">
-              <a:buNone/>
-            </a:pPr>
-            <a:r>
-              <a:rPr sz="2000" b="1"/>
-              <a:t>Note</a:t>
-            </a:r>
-          </a:p>
-          <a:p>
-            <a:pPr lvl="0" indent="0" marL="1270000">
-              <a:buNone/>
-            </a:pPr>
-            <a:r>
-              <a:rPr sz="2000" b="1"/>
-              <a:t>🔮 Predict first (two ways):</a:t>
-            </a:r>
-            <a:r>
-              <a:rPr sz="2000"/>
-              <a:t> how many capture </a:t>
-            </a:r>
-            <a:r>
-              <a:rPr sz="2000" b="1"/>
-              <a:t>events</a:t>
-            </a:r>
-            <a:r>
-              <a:rPr sz="2000"/>
-              <a:t> have no known animal? How many released </a:t>
-            </a:r>
-            <a:r>
-              <a:rPr sz="2000" b="1"/>
-              <a:t>fishers</a:t>
-            </a:r>
-            <a:r>
-              <a:rPr sz="2000"/>
-              <a:t> were never recaptured?</a:t>
+              <a:rPr/>
+              <a:t>📖 R4DS §19.5 — filtering joins</a:t>
             </a:r>
           </a:p>
         </p:txBody>
@@ -6240,6 +6285,45 @@
       </p:grpSpPr>
       <p:sp>
         <p:nvSpPr>
+          <p:cNvPr id="2" name="Title 1"/>
+          <p:cNvSpPr>
+            <a:spLocks noGrp="1"/>
+          </p:cNvSpPr>
+          <p:nvPr>
+            <p:ph type="title"/>
+          </p:nvPr>
+        </p:nvSpPr>
+        <p:spPr>
+          <a:xfrm>
+            <a:off x="0" y="0"/>
+            <a:ext cx="9144000" cy="602780"/>
+          </a:xfrm>
+          <a:solidFill>
+            <a:srgbClr val="1A1A2E"/>
+          </a:solidFill>
+        </p:spPr>
+        <p:txBody>
+          <a:bodyPr/>
+          <a:lstStyle/>
+          <a:p>
+            <a:pPr lvl="0" indent="0" marL="0">
+              <a:buNone/>
+            </a:pPr>
+            <a:r>
+              <a:rPr>
+                <a:latin typeface="Courier"/>
+              </a:rPr>
+              <a:t>semi_join()</a:t>
+            </a:r>
+            <a:r>
+              <a:rPr/>
+              <a:t> — Keep Only What Matched</a:t>
+            </a:r>
+          </a:p>
+        </p:txBody>
+      </p:sp>
+      <p:sp>
+        <p:nvSpPr>
           <p:cNvPr id="3" name="Content Placeholder 2"/>
           <p:cNvSpPr>
             <a:spLocks noGrp="1"/>
@@ -6263,7 +6347,7 @@
                 </a:solidFill>
                 <a:latin typeface="Courier"/>
               </a:rPr>
-              <a:t># (a) capture events of unmarked animals</a:t>
+              <a:t># Released fishers that WERE recaptured at least once</a:t>
             </a:r>
             <a:br/>
             <a:r>
@@ -6273,7 +6357,7 @@
                 </a:solidFill>
                 <a:latin typeface="Courier"/>
               </a:rPr>
-              <a:t>captures_df </a:t>
+              <a:t>individuals_df </a:t>
             </a:r>
             <a:r>
               <a:rPr>
@@ -6301,16 +6385,97 @@
                 </a:solidFill>
                 <a:latin typeface="Courier"/>
               </a:rPr>
-              <a:t>anti_join</a:t>
-            </a:r>
-            <a:r>
-              <a:rPr>
-                <a:solidFill>
-                  <a:srgbClr val="003B4F"/>
-                </a:solidFill>
-                <a:latin typeface="Courier"/>
-              </a:rPr>
-              <a:t>(individuals_df,</a:t>
+              <a:t>semi_join</a:t>
+            </a:r>
+            <a:r>
+              <a:rPr>
+                <a:solidFill>
+                  <a:srgbClr val="003B4F"/>
+                </a:solidFill>
+                <a:latin typeface="Courier"/>
+              </a:rPr>
+              <a:t>(captures_df, </a:t>
+            </a:r>
+            <a:r>
+              <a:rPr>
+                <a:solidFill>
+                  <a:srgbClr val="657422"/>
+                </a:solidFill>
+                <a:latin typeface="Courier"/>
+              </a:rPr>
+              <a:t>by =</a:t>
+            </a:r>
+            <a:r>
+              <a:rPr>
+                <a:solidFill>
+                  <a:srgbClr val="003B4F"/>
+                </a:solidFill>
+                <a:latin typeface="Courier"/>
+              </a:rPr>
+              <a:t> </a:t>
+            </a:r>
+            <a:r>
+              <a:rPr>
+                <a:solidFill>
+                  <a:srgbClr val="4758AB"/>
+                </a:solidFill>
+                <a:latin typeface="Courier"/>
+              </a:rPr>
+              <a:t>c</a:t>
+            </a:r>
+            <a:r>
+              <a:rPr>
+                <a:solidFill>
+                  <a:srgbClr val="003B4F"/>
+                </a:solidFill>
+                <a:latin typeface="Courier"/>
+              </a:rPr>
+              <a:t>(</a:t>
+            </a:r>
+            <a:r>
+              <a:rPr>
+                <a:solidFill>
+                  <a:srgbClr val="20794D"/>
+                </a:solidFill>
+                <a:latin typeface="Courier"/>
+              </a:rPr>
+              <a:t>"fisher_id"</a:t>
+            </a:r>
+            <a:r>
+              <a:rPr>
+                <a:solidFill>
+                  <a:srgbClr val="003B4F"/>
+                </a:solidFill>
+                <a:latin typeface="Courier"/>
+              </a:rPr>
+              <a:t> = </a:t>
+            </a:r>
+            <a:r>
+              <a:rPr>
+                <a:solidFill>
+                  <a:srgbClr val="20794D"/>
+                </a:solidFill>
+                <a:latin typeface="Courier"/>
+              </a:rPr>
+              <a:t>"animal_id"</a:t>
+            </a:r>
+            <a:r>
+              <a:rPr>
+                <a:solidFill>
+                  <a:srgbClr val="003B4F"/>
+                </a:solidFill>
+                <a:latin typeface="Courier"/>
+              </a:rPr>
+              <a:t>)) </a:t>
+            </a:r>
+            <a:r>
+              <a:rPr>
+                <a:solidFill>
+                  <a:srgbClr val="5E5E5E"/>
+                </a:solidFill>
+                <a:latin typeface="Courier"/>
+              </a:rPr>
+              <a:t>%&gt;%</a:t>
             </a:r>
             <a:br/>
             <a:r>
@@ -6320,25 +6485,7 @@
                 </a:solidFill>
                 <a:latin typeface="Courier"/>
               </a:rPr>
-              <a:t>            </a:t>
-            </a:r>
-            <a:r>
-              <a:rPr>
-                <a:solidFill>
-                  <a:srgbClr val="657422"/>
-                </a:solidFill>
-                <a:latin typeface="Courier"/>
-              </a:rPr>
-              <a:t>by =</a:t>
-            </a:r>
-            <a:r>
-              <a:rPr>
-                <a:solidFill>
-                  <a:srgbClr val="003B4F"/>
-                </a:solidFill>
-                <a:latin typeface="Courier"/>
-              </a:rPr>
-              <a:t> </a:t>
+              <a:t>  </a:t>
             </a:r>
             <a:r>
               <a:rPr>
@@ -6347,79 +6494,6 @@
                 </a:solidFill>
                 <a:latin typeface="Courier"/>
               </a:rPr>
-              <a:t>c</a:t>
-            </a:r>
-            <a:r>
-              <a:rPr>
-                <a:solidFill>
-                  <a:srgbClr val="003B4F"/>
-                </a:solidFill>
-                <a:latin typeface="Courier"/>
-              </a:rPr>
-              <a:t>(</a:t>
-            </a:r>
-            <a:r>
-              <a:rPr>
-                <a:solidFill>
-                  <a:srgbClr val="20794D"/>
-                </a:solidFill>
-                <a:latin typeface="Courier"/>
-              </a:rPr>
-              <a:t>"animal_id"</a:t>
-            </a:r>
-            <a:r>
-              <a:rPr>
-                <a:solidFill>
-                  <a:srgbClr val="003B4F"/>
-                </a:solidFill>
-                <a:latin typeface="Courier"/>
-              </a:rPr>
-              <a:t> = </a:t>
-            </a:r>
-            <a:r>
-              <a:rPr>
-                <a:solidFill>
-                  <a:srgbClr val="20794D"/>
-                </a:solidFill>
-                <a:latin typeface="Courier"/>
-              </a:rPr>
-              <a:t>"fisher_id"</a:t>
-            </a:r>
-            <a:r>
-              <a:rPr>
-                <a:solidFill>
-                  <a:srgbClr val="003B4F"/>
-                </a:solidFill>
-                <a:latin typeface="Courier"/>
-              </a:rPr>
-              <a:t>)) </a:t>
-            </a:r>
-            <a:r>
-              <a:rPr>
-                <a:solidFill>
-                  <a:srgbClr val="5E5E5E"/>
-                </a:solidFill>
-                <a:latin typeface="Courier"/>
-              </a:rPr>
-              <a:t>%&gt;%</a:t>
-            </a:r>
-            <a:br/>
-            <a:r>
-              <a:rPr>
-                <a:solidFill>
-                  <a:srgbClr val="003B4F"/>
-                </a:solidFill>
-                <a:latin typeface="Courier"/>
-              </a:rPr>
-              <a:t>  </a:t>
-            </a:r>
-            <a:r>
-              <a:rPr>
-                <a:solidFill>
-                  <a:srgbClr val="4758AB"/>
-                </a:solidFill>
-                <a:latin typeface="Courier"/>
-              </a:rPr>
               <a:t>nrow</a:t>
             </a:r>
             <a:r>
@@ -6440,194 +6514,7 @@
               <a:rPr>
                 <a:latin typeface="Courier"/>
               </a:rPr>
-              <a:t>[1] 3</a:t>
-            </a:r>
-          </a:p>
-          <a:p>
-            <a:pPr lvl="0" indent="0">
-              <a:buNone/>
-            </a:pPr>
-            <a:r>
-              <a:rPr>
-                <a:solidFill>
-                  <a:srgbClr val="5E5E5E"/>
-                </a:solidFill>
-                <a:latin typeface="Courier"/>
-              </a:rPr>
-              <a:t># (b) released fishers with no capture — anti_join the OTHER way</a:t>
-            </a:r>
-            <a:br/>
-            <a:r>
-              <a:rPr>
-                <a:solidFill>
-                  <a:srgbClr val="003B4F"/>
-                </a:solidFill>
-                <a:latin typeface="Courier"/>
-              </a:rPr>
-              <a:t>individuals_df </a:t>
-            </a:r>
-            <a:r>
-              <a:rPr>
-                <a:solidFill>
-                  <a:srgbClr val="5E5E5E"/>
-                </a:solidFill>
-                <a:latin typeface="Courier"/>
-              </a:rPr>
-              <a:t>%&gt;%</a:t>
-            </a:r>
-            <a:br/>
-            <a:r>
-              <a:rPr>
-                <a:solidFill>
-                  <a:srgbClr val="003B4F"/>
-                </a:solidFill>
-                <a:latin typeface="Courier"/>
-              </a:rPr>
-              <a:t>  </a:t>
-            </a:r>
-            <a:r>
-              <a:rPr>
-                <a:solidFill>
-                  <a:srgbClr val="4758AB"/>
-                </a:solidFill>
-                <a:latin typeface="Courier"/>
-              </a:rPr>
-              <a:t>anti_join</a:t>
-            </a:r>
-            <a:r>
-              <a:rPr>
-                <a:solidFill>
-                  <a:srgbClr val="003B4F"/>
-                </a:solidFill>
-                <a:latin typeface="Courier"/>
-              </a:rPr>
-              <a:t>(captures_df, </a:t>
-            </a:r>
-            <a:r>
-              <a:rPr>
-                <a:solidFill>
-                  <a:srgbClr val="657422"/>
-                </a:solidFill>
-                <a:latin typeface="Courier"/>
-              </a:rPr>
-              <a:t>by =</a:t>
-            </a:r>
-            <a:r>
-              <a:rPr>
-                <a:solidFill>
-                  <a:srgbClr val="003B4F"/>
-                </a:solidFill>
-                <a:latin typeface="Courier"/>
-              </a:rPr>
-              <a:t> </a:t>
-            </a:r>
-            <a:r>
-              <a:rPr>
-                <a:solidFill>
-                  <a:srgbClr val="4758AB"/>
-                </a:solidFill>
-                <a:latin typeface="Courier"/>
-              </a:rPr>
-              <a:t>c</a:t>
-            </a:r>
-            <a:r>
-              <a:rPr>
-                <a:solidFill>
-                  <a:srgbClr val="003B4F"/>
-                </a:solidFill>
-                <a:latin typeface="Courier"/>
-              </a:rPr>
-              <a:t>(</a:t>
-            </a:r>
-            <a:r>
-              <a:rPr>
-                <a:solidFill>
-                  <a:srgbClr val="20794D"/>
-                </a:solidFill>
-                <a:latin typeface="Courier"/>
-              </a:rPr>
-              <a:t>"fisher_id"</a:t>
-            </a:r>
-            <a:r>
-              <a:rPr>
-                <a:solidFill>
-                  <a:srgbClr val="003B4F"/>
-                </a:solidFill>
-                <a:latin typeface="Courier"/>
-              </a:rPr>
-              <a:t> = </a:t>
-            </a:r>
-            <a:r>
-              <a:rPr>
-                <a:solidFill>
-                  <a:srgbClr val="20794D"/>
-                </a:solidFill>
-                <a:latin typeface="Courier"/>
-              </a:rPr>
-              <a:t>"animal_id"</a:t>
-            </a:r>
-            <a:r>
-              <a:rPr>
-                <a:solidFill>
-                  <a:srgbClr val="003B4F"/>
-                </a:solidFill>
-                <a:latin typeface="Courier"/>
-              </a:rPr>
-              <a:t>)) </a:t>
-            </a:r>
-            <a:r>
-              <a:rPr>
-                <a:solidFill>
-                  <a:srgbClr val="5E5E5E"/>
-                </a:solidFill>
-                <a:latin typeface="Courier"/>
-              </a:rPr>
-              <a:t>%&gt;%</a:t>
-            </a:r>
-            <a:br/>
-            <a:r>
-              <a:rPr>
-                <a:solidFill>
-                  <a:srgbClr val="003B4F"/>
-                </a:solidFill>
-                <a:latin typeface="Courier"/>
-              </a:rPr>
-              <a:t>  </a:t>
-            </a:r>
-            <a:r>
-              <a:rPr>
-                <a:solidFill>
-                  <a:srgbClr val="4758AB"/>
-                </a:solidFill>
-                <a:latin typeface="Courier"/>
-              </a:rPr>
-              <a:t>select</a:t>
-            </a:r>
-            <a:r>
-              <a:rPr>
-                <a:solidFill>
-                  <a:srgbClr val="003B4F"/>
-                </a:solidFill>
-                <a:latin typeface="Courier"/>
-              </a:rPr>
-              <a:t>(fisher_id, sex, site)</a:t>
-            </a:r>
-          </a:p>
-          <a:p>
-            <a:pPr lvl="0" indent="0">
-              <a:buNone/>
-            </a:pPr>
-            <a:r>
-              <a:rPr>
-                <a:latin typeface="Courier"/>
-              </a:rPr>
-              <a:t># A tibble: 4 × 3
-  fisher_id sex   site           
-  &lt;chr&gt;     &lt;chr&gt; &lt;chr&gt;          
-1 F04       F     Snoqualmie     
-2 F11       F     Gifford Pinchot
-3 F17       M     Snoqualmie     
-4 F18       F     Mt Rainier     </a:t>
+              <a:t>[1] 14</a:t>
             </a:r>
           </a:p>
         </p:txBody>
@@ -6652,50 +6539,77 @@
               <a:rPr b="1">
                 <a:latin typeface="Courier"/>
               </a:rPr>
-              <a:t>anti_join</a:t>
-            </a:r>
-            <a:r>
-              <a:rPr/>
-              <a:t> keeps the left rows with </a:t>
+              <a:t>semi_join</a:t>
+            </a:r>
+            <a:r>
+              <a:rPr/>
+              <a:t> keeps left rows that </a:t>
             </a:r>
             <a:r>
               <a:rPr b="1"/>
-              <a:t>no</a:t>
-            </a:r>
-            <a:r>
-              <a:rPr/>
-              <a:t> match — “what’s missing?”</a:t>
+              <a:t>have</a:t>
+            </a:r>
+            <a:r>
+              <a:rPr/>
+              <a:t> a match — again, </a:t>
+            </a:r>
+            <a:r>
+              <a:rPr b="1"/>
+              <a:t>no new columns</a:t>
             </a:r>
           </a:p>
           <a:p>
             <a:pPr lvl="0"/>
             <a:r>
               <a:rPr/>
-              <a:t>It </a:t>
+              <a:t>Think of </a:t>
+            </a:r>
+            <a:r>
+              <a:rPr>
+                <a:latin typeface="Courier"/>
+              </a:rPr>
+              <a:t>semi</a:t>
+            </a:r>
+            <a:r>
+              <a:rPr/>
+              <a:t>/</a:t>
+            </a:r>
+            <a:r>
+              <a:rPr>
+                <a:latin typeface="Courier"/>
+              </a:rPr>
+              <a:t>anti</a:t>
+            </a:r>
+            <a:r>
+              <a:rPr/>
+              <a:t> as a </a:t>
             </a:r>
             <a:r>
               <a:rPr b="1"/>
-              <a:t>adds no columns</a:t>
-            </a:r>
-            <a:r>
-              <a:rPr/>
-              <a:t> — it filters</a:t>
+              <a:t>filter driven by another table</a:t>
             </a:r>
           </a:p>
           <a:p>
             <a:pPr lvl="0"/>
             <a:r>
-              <a:rPr/>
-              <a:t>Direction matters: run it both ways to see each side’s gaps</a:t>
-            </a:r>
-          </a:p>
-          <a:p>
-            <a:pPr lvl="0" indent="0" marL="0">
-              <a:buNone/>
-            </a:pPr>
-            <a:r>
-              <a:rPr/>
-              <a:t>📖 R4DS §19.5 — filtering joins</a:t>
+              <a:rPr>
+                <a:latin typeface="Courier"/>
+              </a:rPr>
+              <a:t>semi</a:t>
+            </a:r>
+            <a:r>
+              <a:rPr/>
+              <a:t> + </a:t>
+            </a:r>
+            <a:r>
+              <a:rPr>
+                <a:latin typeface="Courier"/>
+              </a:rPr>
+              <a:t>anti</a:t>
+            </a:r>
+            <a:r>
+              <a:rPr/>
+              <a:t> on the same table split it in two: recaptured vs never seen</a:t>
             </a:r>
           </a:p>
         </p:txBody>
@@ -6749,14 +6663,8 @@
               <a:buNone/>
             </a:pPr>
             <a:r>
-              <a:rPr>
-                <a:latin typeface="Courier"/>
-              </a:rPr>
-              <a:t>semi_join()</a:t>
-            </a:r>
-            <a:r>
-              <a:rPr/>
-              <a:t> — Keep Only What Matched</a:t>
+              <a:rPr/>
+              <a:t>The Payoff — Build One Analysis-Ready Table</a:t>
             </a:r>
           </a:p>
         </p:txBody>
@@ -6786,7 +6694,7 @@
                 </a:solidFill>
                 <a:latin typeface="Courier"/>
               </a:rPr>
-              <a:t># Released fishers that WERE recaptured at least once</a:t>
+              <a:t># Every KNOWN-individual capture, with the animal's attributes</a:t>
             </a:r>
             <a:br/>
             <a:r>
@@ -6796,7 +6704,7 @@
                 </a:solidFill>
                 <a:latin typeface="Courier"/>
               </a:rPr>
-              <a:t>individuals_df </a:t>
+              <a:t>fisher_analysis &lt;- captures_df </a:t>
             </a:r>
             <a:r>
               <a:rPr>
@@ -6824,16 +6732,26 @@
                 </a:solidFill>
                 <a:latin typeface="Courier"/>
               </a:rPr>
-              <a:t>semi_join</a:t>
-            </a:r>
-            <a:r>
-              <a:rPr>
-                <a:solidFill>
-                  <a:srgbClr val="003B4F"/>
-                </a:solidFill>
-                <a:latin typeface="Courier"/>
-              </a:rPr>
-              <a:t>(captures_df, </a:t>
+              <a:t>inner_join</a:t>
+            </a:r>
+            <a:r>
+              <a:rPr>
+                <a:solidFill>
+                  <a:srgbClr val="003B4F"/>
+                </a:solidFill>
+                <a:latin typeface="Courier"/>
+              </a:rPr>
+              <a:t>(individuals_df,</a:t>
+            </a:r>
+            <a:br/>
+            <a:r>
+              <a:rPr>
+                <a:solidFill>
+                  <a:srgbClr val="003B4F"/>
+                </a:solidFill>
+                <a:latin typeface="Courier"/>
+              </a:rPr>
+              <a:t>             </a:t>
             </a:r>
             <a:r>
               <a:rPr>
@@ -6878,6 +6796,24 @@
                 </a:solidFill>
                 <a:latin typeface="Courier"/>
               </a:rPr>
+              <a:t>"animal_id"</a:t>
+            </a:r>
+            <a:r>
+              <a:rPr>
+                <a:solidFill>
+                  <a:srgbClr val="003B4F"/>
+                </a:solidFill>
+                <a:latin typeface="Courier"/>
+              </a:rPr>
+              <a:t> = </a:t>
+            </a:r>
+            <a:r>
+              <a:rPr>
+                <a:solidFill>
+                  <a:srgbClr val="20794D"/>
+                </a:solidFill>
+                <a:latin typeface="Courier"/>
+              </a:rPr>
               <a:t>"fisher_id"</a:t>
             </a:r>
             <a:r>
@@ -6887,24 +6823,6 @@
                 </a:solidFill>
                 <a:latin typeface="Courier"/>
               </a:rPr>
-              <a:t> = </a:t>
-            </a:r>
-            <a:r>
-              <a:rPr>
-                <a:solidFill>
-                  <a:srgbClr val="20794D"/>
-                </a:solidFill>
-                <a:latin typeface="Courier"/>
-              </a:rPr>
-              <a:t>"animal_id"</a:t>
-            </a:r>
-            <a:r>
-              <a:rPr>
-                <a:solidFill>
-                  <a:srgbClr val="003B4F"/>
-                </a:solidFill>
-                <a:latin typeface="Courier"/>
-              </a:rPr>
               <a:t>)) </a:t>
             </a:r>
             <a:r>
@@ -6933,7 +6851,166 @@
                 </a:solidFill>
                 <a:latin typeface="Courier"/>
               </a:rPr>
-              <a:t>nrow</a:t>
+              <a:t>mutate</a:t>
+            </a:r>
+            <a:r>
+              <a:rPr>
+                <a:solidFill>
+                  <a:srgbClr val="003B4F"/>
+                </a:solidFill>
+                <a:latin typeface="Courier"/>
+              </a:rPr>
+              <a:t>(</a:t>
+            </a:r>
+            <a:br/>
+            <a:r>
+              <a:rPr>
+                <a:solidFill>
+                  <a:srgbClr val="003B4F"/>
+                </a:solidFill>
+                <a:latin typeface="Courier"/>
+              </a:rPr>
+              <a:t>    </a:t>
+            </a:r>
+            <a:r>
+              <a:rPr>
+                <a:solidFill>
+                  <a:srgbClr val="657422"/>
+                </a:solidFill>
+                <a:latin typeface="Courier"/>
+              </a:rPr>
+              <a:t>days_since_release =</a:t>
+            </a:r>
+            <a:r>
+              <a:rPr>
+                <a:solidFill>
+                  <a:srgbClr val="003B4F"/>
+                </a:solidFill>
+                <a:latin typeface="Courier"/>
+              </a:rPr>
+              <a:t> </a:t>
+            </a:r>
+            <a:r>
+              <a:rPr>
+                <a:solidFill>
+                  <a:srgbClr val="4758AB"/>
+                </a:solidFill>
+                <a:latin typeface="Courier"/>
+              </a:rPr>
+              <a:t>as.numeric</a:t>
+            </a:r>
+            <a:r>
+              <a:rPr>
+                <a:solidFill>
+                  <a:srgbClr val="003B4F"/>
+                </a:solidFill>
+                <a:latin typeface="Courier"/>
+              </a:rPr>
+              <a:t>(capture_date </a:t>
+            </a:r>
+            <a:r>
+              <a:rPr>
+                <a:solidFill>
+                  <a:srgbClr val="5E5E5E"/>
+                </a:solidFill>
+                <a:latin typeface="Courier"/>
+              </a:rPr>
+              <a:t>-</a:t>
+            </a:r>
+            <a:r>
+              <a:rPr>
+                <a:solidFill>
+                  <a:srgbClr val="003B4F"/>
+                </a:solidFill>
+                <a:latin typeface="Courier"/>
+              </a:rPr>
+              <a:t> release_date))</a:t>
+            </a:r>
+            <a:br/>
+            <a:br/>
+            <a:r>
+              <a:rPr>
+                <a:solidFill>
+                  <a:srgbClr val="003B4F"/>
+                </a:solidFill>
+                <a:latin typeface="Courier"/>
+              </a:rPr>
+              <a:t>fisher_analysis </a:t>
+            </a:r>
+            <a:r>
+              <a:rPr>
+                <a:solidFill>
+                  <a:srgbClr val="5E5E5E"/>
+                </a:solidFill>
+                <a:latin typeface="Courier"/>
+              </a:rPr>
+              <a:t>%&gt;%</a:t>
+            </a:r>
+            <a:br/>
+            <a:r>
+              <a:rPr>
+                <a:solidFill>
+                  <a:srgbClr val="003B4F"/>
+                </a:solidFill>
+                <a:latin typeface="Courier"/>
+              </a:rPr>
+              <a:t>  </a:t>
+            </a:r>
+            <a:r>
+              <a:rPr>
+                <a:solidFill>
+                  <a:srgbClr val="4758AB"/>
+                </a:solidFill>
+                <a:latin typeface="Courier"/>
+              </a:rPr>
+              <a:t>select</a:t>
+            </a:r>
+            <a:r>
+              <a:rPr>
+                <a:solidFill>
+                  <a:srgbClr val="003B4F"/>
+                </a:solidFill>
+                <a:latin typeface="Courier"/>
+              </a:rPr>
+              <a:t>(animal_id, sex, age_class, capture_date,</a:t>
+            </a:r>
+            <a:br/>
+            <a:r>
+              <a:rPr>
+                <a:solidFill>
+                  <a:srgbClr val="003B4F"/>
+                </a:solidFill>
+                <a:latin typeface="Courier"/>
+              </a:rPr>
+              <a:t>         days_since_release, mass_kg) </a:t>
+            </a:r>
+            <a:r>
+              <a:rPr>
+                <a:solidFill>
+                  <a:srgbClr val="5E5E5E"/>
+                </a:solidFill>
+                <a:latin typeface="Courier"/>
+              </a:rPr>
+              <a:t>%&gt;%</a:t>
+            </a:r>
+            <a:br/>
+            <a:r>
+              <a:rPr>
+                <a:solidFill>
+                  <a:srgbClr val="003B4F"/>
+                </a:solidFill>
+                <a:latin typeface="Courier"/>
+              </a:rPr>
+              <a:t>  </a:t>
+            </a:r>
+            <a:r>
+              <a:rPr>
+                <a:solidFill>
+                  <a:srgbClr val="4758AB"/>
+                </a:solidFill>
+                <a:latin typeface="Courier"/>
+              </a:rPr>
+              <a:t>head</a:t>
             </a:r>
             <a:r>
               <a:rPr>
@@ -6953,7 +7030,16 @@
               <a:rPr>
                 <a:latin typeface="Courier"/>
               </a:rPr>
-              <a:t>[1] 14</a:t>
+              <a:t># A tibble: 6 × 6
+  animal_id sex   age_class capture_date days_since_release
+  &lt;chr&gt;     &lt;chr&gt; &lt;chr&gt;     &lt;date&gt;                    &lt;dbl&gt;
+1 F03       M     adult     2018-06-08                  121
+2 F09       F     juvenile  2019-02-01                   91
+3 F07       F     juvenile  2019-03-13                  109
+4 F05       M     adult     2019-04-16                  158
+5 F06       F     adult     2019-07-24                  150
+6 F05       M     adult     2019-08-30                  294
+# ℹ 1 more variable: mass_kg &lt;dbl&gt;</a:t>
             </a:r>
           </a:p>
         </p:txBody>
@@ -6973,82 +7059,53 @@
           <a:bodyPr/>
           <a:lstStyle/>
           <a:p>
-            <a:pPr lvl="0"/>
-            <a:r>
-              <a:rPr b="1">
-                <a:latin typeface="Courier"/>
-              </a:rPr>
-              <a:t>semi_join</a:t>
-            </a:r>
-            <a:r>
-              <a:rPr/>
-              <a:t> keeps left rows that </a:t>
-            </a:r>
+            <a:pPr lvl="0" indent="0" marL="0">
+              <a:buNone/>
+            </a:pPr>
             <a:r>
               <a:rPr b="1"/>
-              <a:t>have</a:t>
-            </a:r>
-            <a:r>
-              <a:rPr/>
-              <a:t> a match — again, </a:t>
-            </a:r>
-            <a:r>
-              <a:rPr b="1"/>
-              <a:t>no new columns</a:t>
-            </a:r>
-          </a:p>
-          <a:p>
-            <a:pPr lvl="0"/>
-            <a:r>
-              <a:rPr/>
-              <a:t>Think of </a:t>
-            </a:r>
-            <a:r>
-              <a:rPr>
-                <a:latin typeface="Courier"/>
-              </a:rPr>
-              <a:t>semi</a:t>
-            </a:r>
-            <a:r>
-              <a:rPr/>
-              <a:t>/</a:t>
-            </a:r>
-            <a:r>
-              <a:rPr>
-                <a:latin typeface="Courier"/>
-              </a:rPr>
-              <a:t>anti</a:t>
-            </a:r>
-            <a:r>
-              <a:rPr/>
-              <a:t> as a </a:t>
-            </a:r>
-            <a:r>
-              <a:rPr b="1"/>
-              <a:t>filter driven by another table</a:t>
-            </a:r>
-          </a:p>
-          <a:p>
-            <a:pPr lvl="0"/>
-            <a:r>
-              <a:rPr>
-                <a:latin typeface="Courier"/>
-              </a:rPr>
-              <a:t>semi</a:t>
-            </a:r>
-            <a:r>
-              <a:rPr/>
-              <a:t> + </a:t>
-            </a:r>
-            <a:r>
-              <a:rPr>
-                <a:latin typeface="Courier"/>
-              </a:rPr>
-              <a:t>anti</a:t>
-            </a:r>
-            <a:r>
-              <a:rPr/>
-              <a:t> on the same table split it in two: recaptured vs never seen</a:t>
+              <a:t>You just built a real dataset from two raw ones.</a:t>
+            </a:r>
+            <a:r>
+              <a:rPr/>
+              <a:t> </a:t>
+            </a:r>
+            <a:r>
+              <a:rPr>
+                <a:latin typeface="Courier"/>
+              </a:rPr>
+              <a:t>fisher_analysis</a:t>
+            </a:r>
+            <a:r>
+              <a:rPr/>
+              <a:t> didn’t exist in either source file — every row is a capture event </a:t>
+            </a:r>
+            <a:r>
+              <a:rPr i="1"/>
+              <a:t>plus</a:t>
+            </a:r>
+            <a:r>
+              <a:rPr/>
+              <a:t> the animal’s sex, age, and days-since-release, ready for a model.</a:t>
+            </a:r>
+          </a:p>
+          <a:p>
+            <a:pPr lvl="0" indent="0" marL="0">
+              <a:buNone/>
+            </a:pPr>
+            <a:r>
+              <a:rPr/>
+              <a:t>Here </a:t>
+            </a:r>
+            <a:r>
+              <a:rPr>
+                <a:latin typeface="Courier"/>
+              </a:rPr>
+              <a:t>inner_join</a:t>
+            </a:r>
+            <a:r>
+              <a:rPr/>
+              <a:t> is right: an event with no known animal can’t go into an individual-level analysis.</a:t>
             </a:r>
           </a:p>
         </p:txBody>
@@ -7088,11 +7145,8 @@
         <p:spPr>
           <a:xfrm>
             <a:off x="0" y="0"/>
-            <a:ext cx="9144000" cy="602780"/>
+            <a:ext cx="9144000" cy="582780"/>
           </a:xfrm>
-          <a:solidFill>
-            <a:srgbClr val="1A1A2E"/>
-          </a:solidFill>
         </p:spPr>
         <p:txBody>
           <a:bodyPr/>
@@ -7103,7 +7157,7 @@
             </a:pPr>
             <a:r>
               <a:rPr/>
-              <a:t>The Payoff — Build One Analysis-Ready Table</a:t>
+              <a:t>🛑 Pause — Do Activity Parts 9–11 Now</a:t>
             </a:r>
           </a:p>
         </p:txBody>
@@ -7115,7 +7169,7 @@
             <a:spLocks noGrp="1"/>
           </p:cNvSpPr>
           <p:nvPr>
-            <p:ph idx="1" sz="half"/>
+            <p:ph idx="1"/>
           </p:nvPr>
         </p:nvSpPr>
         <p:spPr/>
@@ -7123,428 +7177,32 @@
           <a:bodyPr/>
           <a:lstStyle/>
           <a:p>
-            <a:pPr lvl="0" indent="0">
-              <a:buNone/>
-            </a:pPr>
-            <a:r>
-              <a:rPr>
-                <a:solidFill>
-                  <a:srgbClr val="5E5E5E"/>
-                </a:solidFill>
-                <a:latin typeface="Courier"/>
-              </a:rPr>
-              <a:t># Every KNOWN-individual capture, with the animal's attributes</a:t>
-            </a:r>
-            <a:br/>
-            <a:r>
-              <a:rPr>
-                <a:solidFill>
-                  <a:srgbClr val="003B4F"/>
-                </a:solidFill>
-                <a:latin typeface="Courier"/>
-              </a:rPr>
-              <a:t>fisher_analysis &lt;- captures_df </a:t>
-            </a:r>
-            <a:r>
-              <a:rPr>
-                <a:solidFill>
-                  <a:srgbClr val="5E5E5E"/>
-                </a:solidFill>
-                <a:latin typeface="Courier"/>
-              </a:rPr>
-              <a:t>%&gt;%</a:t>
-            </a:r>
-            <a:br/>
-            <a:r>
-              <a:rPr>
-                <a:solidFill>
-                  <a:srgbClr val="003B4F"/>
-                </a:solidFill>
-                <a:latin typeface="Courier"/>
-              </a:rPr>
-              <a:t>  </a:t>
-            </a:r>
-            <a:r>
-              <a:rPr>
-                <a:solidFill>
-                  <a:srgbClr val="4758AB"/>
-                </a:solidFill>
-                <a:latin typeface="Courier"/>
-              </a:rPr>
-              <a:t>inner_join</a:t>
-            </a:r>
-            <a:r>
-              <a:rPr>
-                <a:solidFill>
-                  <a:srgbClr val="003B4F"/>
-                </a:solidFill>
-                <a:latin typeface="Courier"/>
-              </a:rPr>
-              <a:t>(individuals_df,</a:t>
-            </a:r>
-            <a:br/>
-            <a:r>
-              <a:rPr>
-                <a:solidFill>
-                  <a:srgbClr val="003B4F"/>
-                </a:solidFill>
-                <a:latin typeface="Courier"/>
-              </a:rPr>
-              <a:t>             </a:t>
-            </a:r>
-            <a:r>
-              <a:rPr>
-                <a:solidFill>
-                  <a:srgbClr val="657422"/>
-                </a:solidFill>
-                <a:latin typeface="Courier"/>
-              </a:rPr>
-              <a:t>by =</a:t>
-            </a:r>
-            <a:r>
-              <a:rPr>
-                <a:solidFill>
-                  <a:srgbClr val="003B4F"/>
-                </a:solidFill>
-                <a:latin typeface="Courier"/>
-              </a:rPr>
-              <a:t> </a:t>
-            </a:r>
-            <a:r>
-              <a:rPr>
-                <a:solidFill>
-                  <a:srgbClr val="4758AB"/>
-                </a:solidFill>
-                <a:latin typeface="Courier"/>
-              </a:rPr>
-              <a:t>c</a:t>
-            </a:r>
-            <a:r>
-              <a:rPr>
-                <a:solidFill>
-                  <a:srgbClr val="003B4F"/>
-                </a:solidFill>
-                <a:latin typeface="Courier"/>
-              </a:rPr>
-              <a:t>(</a:t>
-            </a:r>
-            <a:r>
-              <a:rPr>
-                <a:solidFill>
-                  <a:srgbClr val="20794D"/>
-                </a:solidFill>
-                <a:latin typeface="Courier"/>
-              </a:rPr>
-              <a:t>"animal_id"</a:t>
-            </a:r>
-            <a:r>
-              <a:rPr>
-                <a:solidFill>
-                  <a:srgbClr val="003B4F"/>
-                </a:solidFill>
-                <a:latin typeface="Courier"/>
-              </a:rPr>
-              <a:t> = </a:t>
-            </a:r>
-            <a:r>
-              <a:rPr>
-                <a:solidFill>
-                  <a:srgbClr val="20794D"/>
-                </a:solidFill>
-                <a:latin typeface="Courier"/>
-              </a:rPr>
-              <a:t>"fisher_id"</a:t>
-            </a:r>
-            <a:r>
-              <a:rPr>
-                <a:solidFill>
-                  <a:srgbClr val="003B4F"/>
-                </a:solidFill>
-                <a:latin typeface="Courier"/>
-              </a:rPr>
-              <a:t>)) </a:t>
-            </a:r>
-            <a:r>
-              <a:rPr>
-                <a:solidFill>
-                  <a:srgbClr val="5E5E5E"/>
-                </a:solidFill>
-                <a:latin typeface="Courier"/>
-              </a:rPr>
-              <a:t>%&gt;%</a:t>
-            </a:r>
-            <a:br/>
-            <a:r>
-              <a:rPr>
-                <a:solidFill>
-                  <a:srgbClr val="003B4F"/>
-                </a:solidFill>
-                <a:latin typeface="Courier"/>
-              </a:rPr>
-              <a:t>  </a:t>
-            </a:r>
-            <a:r>
-              <a:rPr>
-                <a:solidFill>
-                  <a:srgbClr val="4758AB"/>
-                </a:solidFill>
-                <a:latin typeface="Courier"/>
-              </a:rPr>
-              <a:t>mutate</a:t>
-            </a:r>
-            <a:r>
-              <a:rPr>
-                <a:solidFill>
-                  <a:srgbClr val="003B4F"/>
-                </a:solidFill>
-                <a:latin typeface="Courier"/>
-              </a:rPr>
-              <a:t>(</a:t>
-            </a:r>
-            <a:br/>
-            <a:r>
-              <a:rPr>
-                <a:solidFill>
-                  <a:srgbClr val="003B4F"/>
-                </a:solidFill>
-                <a:latin typeface="Courier"/>
-              </a:rPr>
-              <a:t>    </a:t>
-            </a:r>
-            <a:r>
-              <a:rPr>
-                <a:solidFill>
-                  <a:srgbClr val="657422"/>
-                </a:solidFill>
-                <a:latin typeface="Courier"/>
-              </a:rPr>
-              <a:t>days_since_release =</a:t>
-            </a:r>
-            <a:r>
-              <a:rPr>
-                <a:solidFill>
-                  <a:srgbClr val="003B4F"/>
-                </a:solidFill>
-                <a:latin typeface="Courier"/>
-              </a:rPr>
-              <a:t> </a:t>
-            </a:r>
-            <a:r>
-              <a:rPr>
-                <a:solidFill>
-                  <a:srgbClr val="4758AB"/>
-                </a:solidFill>
-                <a:latin typeface="Courier"/>
-              </a:rPr>
-              <a:t>as.numeric</a:t>
-            </a:r>
-            <a:r>
-              <a:rPr>
-                <a:solidFill>
-                  <a:srgbClr val="003B4F"/>
-                </a:solidFill>
-                <a:latin typeface="Courier"/>
-              </a:rPr>
-              <a:t>(capture_date </a:t>
-            </a:r>
-            <a:r>
-              <a:rPr>
-                <a:solidFill>
-                  <a:srgbClr val="5E5E5E"/>
-                </a:solidFill>
-                <a:latin typeface="Courier"/>
-              </a:rPr>
-              <a:t>-</a:t>
-            </a:r>
-            <a:r>
-              <a:rPr>
-                <a:solidFill>
-                  <a:srgbClr val="003B4F"/>
-                </a:solidFill>
-                <a:latin typeface="Courier"/>
-              </a:rPr>
-              <a:t> release_date))</a:t>
-            </a:r>
-            <a:br/>
-            <a:br/>
-            <a:r>
-              <a:rPr>
-                <a:solidFill>
-                  <a:srgbClr val="003B4F"/>
-                </a:solidFill>
-                <a:latin typeface="Courier"/>
-              </a:rPr>
-              <a:t>fisher_analysis </a:t>
-            </a:r>
-            <a:r>
-              <a:rPr>
-                <a:solidFill>
-                  <a:srgbClr val="5E5E5E"/>
-                </a:solidFill>
-                <a:latin typeface="Courier"/>
-              </a:rPr>
-              <a:t>%&gt;%</a:t>
-            </a:r>
-            <a:br/>
-            <a:r>
-              <a:rPr>
-                <a:solidFill>
-                  <a:srgbClr val="003B4F"/>
-                </a:solidFill>
-                <a:latin typeface="Courier"/>
-              </a:rPr>
-              <a:t>  </a:t>
-            </a:r>
-            <a:r>
-              <a:rPr>
-                <a:solidFill>
-                  <a:srgbClr val="4758AB"/>
-                </a:solidFill>
-                <a:latin typeface="Courier"/>
-              </a:rPr>
-              <a:t>select</a:t>
-            </a:r>
-            <a:r>
-              <a:rPr>
-                <a:solidFill>
-                  <a:srgbClr val="003B4F"/>
-                </a:solidFill>
-                <a:latin typeface="Courier"/>
-              </a:rPr>
-              <a:t>(animal_id, sex, age_class, capture_date,</a:t>
-            </a:r>
-            <a:br/>
-            <a:r>
-              <a:rPr>
-                <a:solidFill>
-                  <a:srgbClr val="003B4F"/>
-                </a:solidFill>
-                <a:latin typeface="Courier"/>
-              </a:rPr>
-              <a:t>         days_since_release, mass_kg) </a:t>
-            </a:r>
-            <a:r>
-              <a:rPr>
-                <a:solidFill>
-                  <a:srgbClr val="5E5E5E"/>
-                </a:solidFill>
-                <a:latin typeface="Courier"/>
-              </a:rPr>
-              <a:t>%&gt;%</a:t>
-            </a:r>
-            <a:br/>
-            <a:r>
-              <a:rPr>
-                <a:solidFill>
-                  <a:srgbClr val="003B4F"/>
-                </a:solidFill>
-                <a:latin typeface="Courier"/>
-              </a:rPr>
-              <a:t>  </a:t>
-            </a:r>
-            <a:r>
-              <a:rPr>
-                <a:solidFill>
-                  <a:srgbClr val="4758AB"/>
-                </a:solidFill>
-                <a:latin typeface="Courier"/>
-              </a:rPr>
-              <a:t>head</a:t>
-            </a:r>
-            <a:r>
-              <a:rPr>
-                <a:solidFill>
-                  <a:srgbClr val="003B4F"/>
-                </a:solidFill>
-                <a:latin typeface="Courier"/>
-              </a:rPr>
-              <a:t>()</a:t>
-            </a:r>
-          </a:p>
-          <a:p>
-            <a:pPr lvl="0" indent="0">
-              <a:buNone/>
-            </a:pPr>
-            <a:r>
-              <a:rPr>
-                <a:latin typeface="Courier"/>
-              </a:rPr>
-              <a:t># A tibble: 6 × 6
-  animal_id sex   age_class capture_date days_since_release
-  &lt;chr&gt;     &lt;chr&gt; &lt;chr&gt;     &lt;date&gt;                    &lt;dbl&gt;
-1 F03       M     adult     2018-06-08                  121
-2 F09       F     juvenile  2019-02-01                   91
-3 F07       F     juvenile  2019-03-13                  109
-4 F05       M     adult     2019-04-16                  158
-5 F06       F     adult     2019-07-24                  150
-6 F05       M     adult     2019-08-30                  294
-# ℹ 1 more variable: mass_kg &lt;dbl&gt;</a:t>
-            </a:r>
-          </a:p>
-        </p:txBody>
-      </p:sp>
-      <p:sp>
-        <p:nvSpPr>
-          <p:cNvPr id="4" name="Content Placeholder 3"/>
-          <p:cNvSpPr>
-            <a:spLocks noGrp="1"/>
-          </p:cNvSpPr>
-          <p:nvPr>
-            <p:ph idx="2" sz="half"/>
-          </p:nvPr>
-        </p:nvSpPr>
-        <p:spPr/>
-        <p:txBody>
-          <a:bodyPr/>
-          <a:lstStyle/>
-          <a:p>
             <a:pPr lvl="0" indent="0" marL="0">
               <a:buNone/>
             </a:pPr>
             <a:r>
-              <a:rPr b="1"/>
-              <a:t>You just built a real dataset from two raw ones.</a:t>
-            </a:r>
-            <a:r>
-              <a:rPr/>
-              <a:t> </a:t>
-            </a:r>
-            <a:r>
-              <a:rPr>
-                <a:latin typeface="Courier"/>
-              </a:rPr>
-              <a:t>fisher_analysis</a:t>
-            </a:r>
-            <a:r>
-              <a:rPr/>
-              <a:t> didn’t exist in either source file — every row is a capture event </a:t>
-            </a:r>
-            <a:r>
-              <a:rPr i="1"/>
-              <a:t>plus</a:t>
-            </a:r>
-            <a:r>
-              <a:rPr/>
-              <a:t> the animal’s sex, age, and days-since-release, ready for a model.</a:t>
-            </a:r>
-          </a:p>
-          <a:p>
-            <a:pPr lvl="0" indent="0" marL="0">
-              <a:buNone/>
-            </a:pPr>
-            <a:r>
-              <a:rPr/>
-              <a:t>Here </a:t>
-            </a:r>
-            <a:r>
-              <a:rPr>
-                <a:latin typeface="Courier"/>
-              </a:rPr>
-              <a:t>inner_join</a:t>
-            </a:r>
-            <a:r>
-              <a:rPr/>
-              <a:t> is right: an event with no known animal can’t go into an individual-level analysis.</a:t>
+              <a:rPr/>
+              <a:t>Use </a:t>
+            </a:r>
+            <a:r>
+              <a:rPr>
+                <a:latin typeface="Courier"/>
+              </a:rPr>
+              <a:t>anti_join</a:t>
+            </a:r>
+            <a:r>
+              <a:rPr/>
+              <a:t> both directions to find the gaps, </a:t>
+            </a:r>
+            <a:r>
+              <a:rPr>
+                <a:latin typeface="Courier"/>
+              </a:rPr>
+              <a:t>semi_join</a:t>
+            </a:r>
+            <a:r>
+              <a:rPr/>
+              <a:t> to see who was recaptured, and build the combined table. Predict the counts first.</a:t>
             </a:r>
           </a:p>
         </p:txBody>
@@ -7555,103 +7213,6 @@
 </file>
 
 <file path=ppt/slides/slide25.xml><?xml version="1.0" encoding="utf-8"?>
-<p:sld xmlns:a="http://schemas.openxmlformats.org/drawingml/2006/main" xmlns:r="http://schemas.openxmlformats.org/officeDocument/2006/relationships" xmlns:p="http://schemas.openxmlformats.org/presentationml/2006/main">
-  <p:cSld>
-    <p:spTree>
-      <p:nvGrpSpPr>
-        <p:cNvPr id="1" name=""/>
-        <p:cNvGrpSpPr/>
-        <p:nvPr/>
-      </p:nvGrpSpPr>
-      <p:grpSpPr>
-        <a:xfrm>
-          <a:off x="0" y="0"/>
-          <a:ext cx="0" cy="0"/>
-          <a:chOff x="0" y="0"/>
-          <a:chExt cx="0" cy="0"/>
-        </a:xfrm>
-      </p:grpSpPr>
-      <p:sp>
-        <p:nvSpPr>
-          <p:cNvPr id="2" name="Title 1"/>
-          <p:cNvSpPr>
-            <a:spLocks noGrp="1"/>
-          </p:cNvSpPr>
-          <p:nvPr>
-            <p:ph type="title"/>
-          </p:nvPr>
-        </p:nvSpPr>
-        <p:spPr>
-          <a:xfrm>
-            <a:off x="0" y="0"/>
-            <a:ext cx="9144000" cy="582780"/>
-          </a:xfrm>
-        </p:spPr>
-        <p:txBody>
-          <a:bodyPr/>
-          <a:lstStyle/>
-          <a:p>
-            <a:pPr lvl="0" indent="0" marL="0">
-              <a:buNone/>
-            </a:pPr>
-            <a:r>
-              <a:rPr/>
-              <a:t>🛑 Pause — Do Activity Parts 10–12 Now</a:t>
-            </a:r>
-          </a:p>
-        </p:txBody>
-      </p:sp>
-      <p:sp>
-        <p:nvSpPr>
-          <p:cNvPr id="3" name="Content Placeholder 2"/>
-          <p:cNvSpPr>
-            <a:spLocks noGrp="1"/>
-          </p:cNvSpPr>
-          <p:nvPr>
-            <p:ph idx="1"/>
-          </p:nvPr>
-        </p:nvSpPr>
-        <p:spPr/>
-        <p:txBody>
-          <a:bodyPr/>
-          <a:lstStyle/>
-          <a:p>
-            <a:pPr lvl="0" indent="0" marL="0">
-              <a:buNone/>
-            </a:pPr>
-            <a:r>
-              <a:rPr/>
-              <a:t>Use </a:t>
-            </a:r>
-            <a:r>
-              <a:rPr>
-                <a:latin typeface="Courier"/>
-              </a:rPr>
-              <a:t>anti_join</a:t>
-            </a:r>
-            <a:r>
-              <a:rPr/>
-              <a:t> both directions to find the gaps, </a:t>
-            </a:r>
-            <a:r>
-              <a:rPr>
-                <a:latin typeface="Courier"/>
-              </a:rPr>
-              <a:t>semi_join</a:t>
-            </a:r>
-            <a:r>
-              <a:rPr/>
-              <a:t> to see who was recaptured, and build the combined table. Predict the counts first.</a:t>
-            </a:r>
-          </a:p>
-        </p:txBody>
-      </p:sp>
-    </p:spTree>
-  </p:cSld>
-</p:sld>
-</file>
-
-<file path=ppt/slides/slide26.xml><?xml version="1.0" encoding="utf-8"?>
 <p:sld xmlns:a="http://schemas.openxmlformats.org/drawingml/2006/main" xmlns:r="http://schemas.openxmlformats.org/officeDocument/2006/relationships" xmlns:p="http://schemas.openxmlformats.org/presentationml/2006/main">
   <p:cSld>
     <p:spTree>

</xml_diff>